<commit_message>
feat: generate and persist guardian reply videos
</commit_message>
<xml_diff>
--- a/docs/architecture/AI_HACK_2026_AWS_style_architecture.pptx
+++ b/docs/architecture/AI_HACK_2026_AWS_style_architecture.pptx
@@ -2,14 +2,14 @@
 <file path=ppt/presentation.xml><?xml version="1.0" encoding="utf-8"?>
 <p:presentation xmlns:p="http://schemas.openxmlformats.org/presentationml/2006/main">
   <p:sldMasterIdLst>
-    <p:sldMasterId xmlns:r="http://schemas.openxmlformats.org/officeDocument/2006/relationships" id="2147483648" r:id="Rd9d1852ed12c4ae3"/>
+    <p:sldMasterId xmlns:r="http://schemas.openxmlformats.org/officeDocument/2006/relationships" id="2147483648" r:id="Rcb023ecbf0ed4d90"/>
   </p:sldMasterIdLst>
   <p:notesMasterIdLst>
-    <p:notesMasterId xmlns:r="http://schemas.openxmlformats.org/officeDocument/2006/relationships" r:id="R8df2eb02f57e45c9"/>
+    <p:notesMasterId xmlns:r="http://schemas.openxmlformats.org/officeDocument/2006/relationships" r:id="R446f34a1a3e0493e"/>
   </p:notesMasterIdLst>
   <p:sldIdLst>
-    <p:sldId xmlns:r="http://schemas.openxmlformats.org/officeDocument/2006/relationships" id="256" r:id="R9158b6e898e744cc"/>
-    <p:sldId xmlns:r="http://schemas.openxmlformats.org/officeDocument/2006/relationships" id="257" r:id="R06712ec99ecd4a3a"/>
+    <p:sldId xmlns:r="http://schemas.openxmlformats.org/officeDocument/2006/relationships" id="256" r:id="R8eadfa80d3284e8f"/>
+    <p:sldId xmlns:r="http://schemas.openxmlformats.org/officeDocument/2006/relationships" id="257" r:id="Rd9e7b91d124b41dd"/>
   </p:sldIdLst>
   <p:sldSz cx="12192000" cy="6858000"/>
   <p:notesSz cx="6858000" cy="9144000"/>
@@ -448,22 +448,22 @@
           </a:p>
           <a:p xmlns:a="http://schemas.openxmlformats.org/drawingml/2006/main">
             <a:r>
-              <a:t>- README.md（現在の実装、OrcaRouterの役割、LEVEL 3、暗号化保存）</a:t>
-            </a:r>
-          </a:p>
-          <a:p xmlns:a="http://schemas.openxmlformats.org/drawingml/2006/main">
-            <a:r>
-              <a:t>- public/app.js（sessionId、ブラウザTTS、写真アニメーション）</a:t>
-            </a:r>
-          </a:p>
-          <a:p xmlns:a="http://schemas.openxmlformats.org/drawingml/2006/main">
-            <a:r>
-              <a:t>- server.mjs（Node API、判定、返答バンドル）</a:t>
-            </a:r>
-          </a:p>
-          <a:p xmlns:a="http://schemas.openxmlformats.org/drawingml/2006/main">
-            <a:r>
-              <a:t>- lib/providers/stt.mjs / orcarouter.mjs / media.mjs（プロバイダー境界）</a:t>
+              <a:t>- README.md（現在の実装、OrcaRouterの役割、生成動画、暗号化保存）</a:t>
+            </a:r>
+          </a:p>
+          <a:p xmlns:a="http://schemas.openxmlformats.org/drawingml/2006/main">
+            <a:r>
+              <a:t>- public/app.js（conversationId、生成MP4・ブラウザ音声・字幕の同時再生）</a:t>
+            </a:r>
+          </a:p>
+          <a:p xmlns:a="http://schemas.openxmlformats.org/drawingml/2006/main">
+            <a:r>
+              <a:t>- server.mjs（Node API、動画生成ジョブ、判定、返答バンドル）</a:t>
+            </a:r>
+          </a:p>
+          <a:p xmlns:a="http://schemas.openxmlformats.org/drawingml/2006/main">
+            <a:r>
+              <a:t>- lib/providers/stt.mjs / orcarouter.mjs / kling-video.mjs / media.mjs（プロバイダー境界）</a:t>
             </a:r>
           </a:p>
           <a:p xmlns:a="http://schemas.openxmlformats.org/drawingml/2006/main">
@@ -548,22 +548,22 @@
           </a:p>
           <a:p xmlns:a="http://schemas.openxmlformats.org/drawingml/2006/main">
             <a:r>
-              <a:t>- https://docs.orcarouter.ai/other-apis/tts（/v1/audio/speech とGemini /v1beta/）</a:t>
-            </a:r>
-          </a:p>
-          <a:p xmlns:a="http://schemas.openxmlformats.org/drawingml/2006/main">
-            <a:r>
-              <a:t>- https://docs.orcarouter.ai/kling-video/overview（非同期 /v1/video/generations、典型30〜90秒）</a:t>
-            </a:r>
-          </a:p>
-          <a:p xmlns:a="http://schemas.openxmlformats.org/drawingml/2006/main">
-            <a:r>
-              <a:t>- https://docs.orcarouter.ai/seedance-video/overview（非同期submit/poll、典型30秒〜4分）</a:t>
-            </a:r>
-          </a:p>
-          <a:p xmlns:a="http://schemas.openxmlformats.org/drawingml/2006/main">
-            <a:r>
-              <a:t>- README.md / lib/providers/media.mjs（現行実装とLEVEL 1〜4境界）</a:t>
+              <a:t>- https://docs.orcarouter.ai/other-apis/tts（将来候補の同期TTS）</a:t>
+            </a:r>
+          </a:p>
+          <a:p xmlns:a="http://schemas.openxmlformats.org/drawingml/2006/main">
+            <a:r>
+              <a:t>- https://docs.orcarouter.ai/kling-video/overview（非同期 /v1/video/generations、典型30〜90秒、image_list）</a:t>
+            </a:r>
+          </a:p>
+          <a:p xmlns:a="http://schemas.openxmlformats.org/drawingml/2006/main">
+            <a:r>
+              <a:t>- README.md / server.mjs / lib/providers/kling-video.mjs（実装済みKlingジョブと保存）</a:t>
+            </a:r>
+          </a:p>
+          <a:p xmlns:a="http://schemas.openxmlformats.org/drawingml/2006/main">
+            <a:r>
+              <a:t>- public/app.js（保存動画・動的音声・字幕の同時再生）</a:t>
             </a:r>
           </a:p>
           <a:p xmlns:a="http://schemas.openxmlformats.org/drawingml/2006/main">
@@ -636,7 +636,7 @@
   </p:cSld>
   <p:clrMap bg1="lt1" tx1="dk1" bg2="lt2" tx2="dk2" accent1="accent1" accent2="accent2" accent3="accent3" accent4="accent4" accent5="accent5" accent6="accent6" hlink="hlink" folHlink="folHlink"/>
   <p:sldLayoutIdLst>
-    <p:sldLayoutId xmlns:r="http://schemas.openxmlformats.org/officeDocument/2006/relationships" id="2147483649" r:id="Rb4cb6640fc824833"/>
+    <p:sldLayoutId xmlns:r="http://schemas.openxmlformats.org/officeDocument/2006/relationships" id="2147483649" r:id="R0233bcfc6ab64976"/>
   </p:sldLayoutIdLst>
   <p:txStyles>
     <p:titleStyle>
@@ -1187,7 +1187,7 @@
           <p:cNvPr id="82" name="slide-1-title">
             <a:extLst xmlns:a="http://schemas.openxmlformats.org/drawingml/2006/main">
               <a:ext uri="{FF2B5EF4-FFF2-40B4-BE49-F238E27FC236}">
-                <a16:creationId xmlns:a16="http://schemas.microsoft.com/office/drawing/2014/main" id="{C6ED3A71-E9CF-4640-88B3-013DA577F90A}"/>
+                <a16:creationId xmlns:a16="http://schemas.microsoft.com/office/drawing/2014/main" id="{455CF5A7-65D3-44EB-88DD-A8DB73E2D562}"/>
               </a:ext>
             </a:extLst>
           </p:cNvPr>
@@ -1237,7 +1237,7 @@
           <p:cNvPr id="2" name="slide-1-subtitle">
             <a:extLst xmlns:a="http://schemas.openxmlformats.org/drawingml/2006/main">
               <a:ext uri="{FF2B5EF4-FFF2-40B4-BE49-F238E27FC236}">
-                <a16:creationId xmlns:a16="http://schemas.microsoft.com/office/drawing/2014/main" id="{A1663BDF-4C5F-485E-9747-1A6B5DCE66DD}"/>
+                <a16:creationId xmlns:a16="http://schemas.microsoft.com/office/drawing/2014/main" id="{AAD8E03D-0396-471C-892D-DA5B2F851F4E}"/>
               </a:ext>
             </a:extLst>
           </p:cNvPr>
@@ -1277,7 +1277,7 @@
                   <a:srgbClr val="5D7180"/>
                 </a:solidFill>
               </a:rPr>
-              <a:t>現行MVP：判断はOrcaRouter、提示はブラウザで同時にそろえる</a:t>
+              <a:t>現行MVP：OrcaRouterが判断し、生成済み親動画・動的音声・字幕を同時提示</a:t>
             </a:r>
           </a:p>
         </p:txBody>
@@ -1287,7 +1287,7 @@
           <p:cNvPr id="3" name="slide-1-number">
             <a:extLst xmlns:a="http://schemas.openxmlformats.org/drawingml/2006/main">
               <a:ext uri="{FF2B5EF4-FFF2-40B4-BE49-F238E27FC236}">
-                <a16:creationId xmlns:a16="http://schemas.microsoft.com/office/drawing/2014/main" id="{1DC6F079-88C8-41A1-86A3-345288E9A79C}"/>
+                <a16:creationId xmlns:a16="http://schemas.microsoft.com/office/drawing/2014/main" id="{7119BA37-AB1B-43CC-802F-374CC17E10C5}"/>
               </a:ext>
             </a:extLst>
           </p:cNvPr>
@@ -1337,7 +1337,7 @@
           <p:cNvPr id="4" name="browser-region">
             <a:extLst xmlns:a="http://schemas.openxmlformats.org/drawingml/2006/main">
               <a:ext uri="{FF2B5EF4-FFF2-40B4-BE49-F238E27FC236}">
-                <a16:creationId xmlns:a16="http://schemas.microsoft.com/office/drawing/2014/main" id="{1C80A679-9B69-4CED-B7E1-F5F89F4133B3}"/>
+                <a16:creationId xmlns:a16="http://schemas.microsoft.com/office/drawing/2014/main" id="{2F290795-36C3-4D92-B85C-3F6D098D61B5}"/>
               </a:ext>
             </a:extLst>
           </p:cNvPr>
@@ -1370,7 +1370,7 @@
           <p:cNvPr id="5" name="browser-region-label">
             <a:extLst xmlns:a="http://schemas.openxmlformats.org/drawingml/2006/main">
               <a:ext uri="{FF2B5EF4-FFF2-40B4-BE49-F238E27FC236}">
-                <a16:creationId xmlns:a16="http://schemas.microsoft.com/office/drawing/2014/main" id="{9F21D254-9DF0-4655-BBE3-82EE72AE1754}"/>
+                <a16:creationId xmlns:a16="http://schemas.microsoft.com/office/drawing/2014/main" id="{1F7F0AF4-1419-4956-9A39-CAC7920793A6}"/>
               </a:ext>
             </a:extLst>
           </p:cNvPr>
@@ -1420,7 +1420,7 @@
           <p:cNvPr id="6" name="server-region">
             <a:extLst xmlns:a="http://schemas.openxmlformats.org/drawingml/2006/main">
               <a:ext uri="{FF2B5EF4-FFF2-40B4-BE49-F238E27FC236}">
-                <a16:creationId xmlns:a16="http://schemas.microsoft.com/office/drawing/2014/main" id="{995952F9-35B9-4026-A9BF-66533F6BE15E}"/>
+                <a16:creationId xmlns:a16="http://schemas.microsoft.com/office/drawing/2014/main" id="{BCDF613E-3551-4FD9-85BE-D0687CD4F721}"/>
               </a:ext>
             </a:extLst>
           </p:cNvPr>
@@ -1453,7 +1453,7 @@
           <p:cNvPr id="7" name="server-region-label">
             <a:extLst xmlns:a="http://schemas.openxmlformats.org/drawingml/2006/main">
               <a:ext uri="{FF2B5EF4-FFF2-40B4-BE49-F238E27FC236}">
-                <a16:creationId xmlns:a16="http://schemas.microsoft.com/office/drawing/2014/main" id="{78B304D7-F47D-4687-9C37-A77DD136DD25}"/>
+                <a16:creationId xmlns:a16="http://schemas.microsoft.com/office/drawing/2014/main" id="{E0D8AB57-074B-4909-91F2-60A136998326}"/>
               </a:ext>
             </a:extLst>
           </p:cNvPr>
@@ -1503,7 +1503,7 @@
           <p:cNvPr id="8" name="a-child-capture">
             <a:extLst xmlns:a="http://schemas.openxmlformats.org/drawingml/2006/main">
               <a:ext uri="{FF2B5EF4-FFF2-40B4-BE49-F238E27FC236}">
-                <a16:creationId xmlns:a16="http://schemas.microsoft.com/office/drawing/2014/main" id="{4F7F326D-FD0C-495B-91EE-D726BA7F4E6C}"/>
+                <a16:creationId xmlns:a16="http://schemas.microsoft.com/office/drawing/2014/main" id="{A467B11B-08D3-4E1A-B727-B2B34A9B054F}"/>
               </a:ext>
             </a:extLst>
           </p:cNvPr>
@@ -1534,7 +1534,7 @@
           <p:cNvPr id="9" name="a-child-capture-head">
             <a:extLst xmlns:a="http://schemas.openxmlformats.org/drawingml/2006/main">
               <a:ext uri="{FF2B5EF4-FFF2-40B4-BE49-F238E27FC236}">
-                <a16:creationId xmlns:a16="http://schemas.microsoft.com/office/drawing/2014/main" id="{E8DA4847-F4B6-450F-9FB2-AD460779575F}"/>
+                <a16:creationId xmlns:a16="http://schemas.microsoft.com/office/drawing/2014/main" id="{D819B7B0-23AF-465B-9EAA-89B9AB3256BB}"/>
               </a:ext>
             </a:extLst>
           </p:cNvPr>
@@ -1567,7 +1567,7 @@
           <p:cNvPr id="10" name="a-capture-ui">
             <a:extLst xmlns:a="http://schemas.openxmlformats.org/drawingml/2006/main">
               <a:ext uri="{FF2B5EF4-FFF2-40B4-BE49-F238E27FC236}">
-                <a16:creationId xmlns:a16="http://schemas.microsoft.com/office/drawing/2014/main" id="{B10B9EC6-71C0-4329-97E5-68382C18B68A}"/>
+                <a16:creationId xmlns:a16="http://schemas.microsoft.com/office/drawing/2014/main" id="{18EB2FBD-D9B2-4811-AE71-A98787A54276}"/>
               </a:ext>
             </a:extLst>
           </p:cNvPr>
@@ -1598,7 +1598,7 @@
           <p:cNvPr id="11" name="a-capture-ui-head">
             <a:extLst xmlns:a="http://schemas.openxmlformats.org/drawingml/2006/main">
               <a:ext uri="{FF2B5EF4-FFF2-40B4-BE49-F238E27FC236}">
-                <a16:creationId xmlns:a16="http://schemas.microsoft.com/office/drawing/2014/main" id="{A761E389-54D6-47FD-BF27-9AB0D7EA4414}"/>
+                <a16:creationId xmlns:a16="http://schemas.microsoft.com/office/drawing/2014/main" id="{0D7D1EA9-EE4B-4BAE-9C07-723A4472062C}"/>
               </a:ext>
             </a:extLst>
           </p:cNvPr>
@@ -1631,7 +1631,7 @@
           <p:cNvPr id="12" name="a-ui-api">
             <a:extLst xmlns:a="http://schemas.openxmlformats.org/drawingml/2006/main">
               <a:ext uri="{FF2B5EF4-FFF2-40B4-BE49-F238E27FC236}">
-                <a16:creationId xmlns:a16="http://schemas.microsoft.com/office/drawing/2014/main" id="{3E2DB31D-8164-47C8-A309-984F20E5F035}"/>
+                <a16:creationId xmlns:a16="http://schemas.microsoft.com/office/drawing/2014/main" id="{1DD904E1-84FF-47D1-A7EF-1749589665DA}"/>
               </a:ext>
             </a:extLst>
           </p:cNvPr>
@@ -1662,7 +1662,7 @@
           <p:cNvPr id="13" name="a-ui-api-head">
             <a:extLst xmlns:a="http://schemas.openxmlformats.org/drawingml/2006/main">
               <a:ext uri="{FF2B5EF4-FFF2-40B4-BE49-F238E27FC236}">
-                <a16:creationId xmlns:a16="http://schemas.microsoft.com/office/drawing/2014/main" id="{DB649655-F9E0-4736-AFFF-A4A7C8F0B6BF}"/>
+                <a16:creationId xmlns:a16="http://schemas.microsoft.com/office/drawing/2014/main" id="{8EB488CC-A5B5-43DA-9EA7-09E0C5CAA3EE}"/>
               </a:ext>
             </a:extLst>
           </p:cNvPr>
@@ -1695,7 +1695,7 @@
           <p:cNvPr id="14" name="a-api-router">
             <a:extLst xmlns:a="http://schemas.openxmlformats.org/drawingml/2006/main">
               <a:ext uri="{FF2B5EF4-FFF2-40B4-BE49-F238E27FC236}">
-                <a16:creationId xmlns:a16="http://schemas.microsoft.com/office/drawing/2014/main" id="{52F35A86-BAC0-4420-89CC-30644624482D}"/>
+                <a16:creationId xmlns:a16="http://schemas.microsoft.com/office/drawing/2014/main" id="{6D4F7E11-DFEF-4629-97FB-56A274332D97}"/>
               </a:ext>
             </a:extLst>
           </p:cNvPr>
@@ -1726,7 +1726,7 @@
           <p:cNvPr id="15" name="a-api-router-head">
             <a:extLst xmlns:a="http://schemas.openxmlformats.org/drawingml/2006/main">
               <a:ext uri="{FF2B5EF4-FFF2-40B4-BE49-F238E27FC236}">
-                <a16:creationId xmlns:a16="http://schemas.microsoft.com/office/drawing/2014/main" id="{316D4037-1379-4801-B842-CE128FE6149E}"/>
+                <a16:creationId xmlns:a16="http://schemas.microsoft.com/office/drawing/2014/main" id="{93A2E10F-D9FC-4214-99CE-75A1F26DB935}"/>
               </a:ext>
             </a:extLst>
           </p:cNvPr>
@@ -1759,7 +1759,7 @@
           <p:cNvPr id="16" name="a-router-branches">
             <a:extLst xmlns:a="http://schemas.openxmlformats.org/drawingml/2006/main">
               <a:ext uri="{FF2B5EF4-FFF2-40B4-BE49-F238E27FC236}">
-                <a16:creationId xmlns:a16="http://schemas.microsoft.com/office/drawing/2014/main" id="{397B3ECD-D439-4678-B686-D2B1F214CBFE}"/>
+                <a16:creationId xmlns:a16="http://schemas.microsoft.com/office/drawing/2014/main" id="{2D00817B-0629-410B-A509-42EF1C66020D}"/>
               </a:ext>
             </a:extLst>
           </p:cNvPr>
@@ -1790,7 +1790,7 @@
           <p:cNvPr id="17" name="a-router-branches-head">
             <a:extLst xmlns:a="http://schemas.openxmlformats.org/drawingml/2006/main">
               <a:ext uri="{FF2B5EF4-FFF2-40B4-BE49-F238E27FC236}">
-                <a16:creationId xmlns:a16="http://schemas.microsoft.com/office/drawing/2014/main" id="{C687AFC2-D1CC-401D-A2C6-554424D4B9CC}"/>
+                <a16:creationId xmlns:a16="http://schemas.microsoft.com/office/drawing/2014/main" id="{02B10054-4302-4AC8-AEFF-C7B70C45573F}"/>
               </a:ext>
             </a:extLst>
           </p:cNvPr>
@@ -1823,7 +1823,7 @@
           <p:cNvPr id="18" name="a-branch-output">
             <a:extLst xmlns:a="http://schemas.openxmlformats.org/drawingml/2006/main">
               <a:ext uri="{FF2B5EF4-FFF2-40B4-BE49-F238E27FC236}">
-                <a16:creationId xmlns:a16="http://schemas.microsoft.com/office/drawing/2014/main" id="{B5A7908B-9D2E-4160-9BCA-F522C859FE89}"/>
+                <a16:creationId xmlns:a16="http://schemas.microsoft.com/office/drawing/2014/main" id="{0F40D589-1E3B-41C6-B2E9-68F2941FDCAA}"/>
               </a:ext>
             </a:extLst>
           </p:cNvPr>
@@ -1854,7 +1854,7 @@
           <p:cNvPr id="19" name="a-branch-output-head">
             <a:extLst xmlns:a="http://schemas.openxmlformats.org/drawingml/2006/main">
               <a:ext uri="{FF2B5EF4-FFF2-40B4-BE49-F238E27FC236}">
-                <a16:creationId xmlns:a16="http://schemas.microsoft.com/office/drawing/2014/main" id="{109FB620-CC25-4E60-91A7-083A3F0EBF43}"/>
+                <a16:creationId xmlns:a16="http://schemas.microsoft.com/office/drawing/2014/main" id="{2F151BBF-2296-4D53-82E5-702D8FE6111D}"/>
               </a:ext>
             </a:extLst>
           </p:cNvPr>
@@ -1887,7 +1887,7 @@
           <p:cNvPr id="20" name="a-output-browser">
             <a:extLst xmlns:a="http://schemas.openxmlformats.org/drawingml/2006/main">
               <a:ext uri="{FF2B5EF4-FFF2-40B4-BE49-F238E27FC236}">
-                <a16:creationId xmlns:a16="http://schemas.microsoft.com/office/drawing/2014/main" id="{3FFE3AA8-3538-4E4E-A9F0-323DA96BEB17}"/>
+                <a16:creationId xmlns:a16="http://schemas.microsoft.com/office/drawing/2014/main" id="{82EEEB23-436E-4D7B-9E14-50592F5A3765}"/>
               </a:ext>
             </a:extLst>
           </p:cNvPr>
@@ -1918,7 +1918,7 @@
           <p:cNvPr id="21" name="a-output-browser-head">
             <a:extLst xmlns:a="http://schemas.openxmlformats.org/drawingml/2006/main">
               <a:ext uri="{FF2B5EF4-FFF2-40B4-BE49-F238E27FC236}">
-                <a16:creationId xmlns:a16="http://schemas.microsoft.com/office/drawing/2014/main" id="{4E9544A6-C686-45D1-9FEA-FA56892BA6FB}"/>
+                <a16:creationId xmlns:a16="http://schemas.microsoft.com/office/drawing/2014/main" id="{09B8EEED-1DE3-4C76-961B-C5C5E6AACCBE}"/>
               </a:ext>
             </a:extLst>
           </p:cNvPr>
@@ -1951,7 +1951,7 @@
           <p:cNvPr id="22" name="child">
             <a:extLst xmlns:a="http://schemas.openxmlformats.org/drawingml/2006/main">
               <a:ext uri="{FF2B5EF4-FFF2-40B4-BE49-F238E27FC236}">
-                <a16:creationId xmlns:a16="http://schemas.microsoft.com/office/drawing/2014/main" id="{7BF2DE10-47CE-4694-8897-81724C547094}"/>
+                <a16:creationId xmlns:a16="http://schemas.microsoft.com/office/drawing/2014/main" id="{C0C10E09-A63D-4D07-B8F5-CDECDEF88703}"/>
               </a:ext>
             </a:extLst>
           </p:cNvPr>
@@ -1986,7 +1986,7 @@
           <p:cNvPr id="23" name="child-accent">
             <a:extLst xmlns:a="http://schemas.openxmlformats.org/drawingml/2006/main">
               <a:ext uri="{FF2B5EF4-FFF2-40B4-BE49-F238E27FC236}">
-                <a16:creationId xmlns:a16="http://schemas.microsoft.com/office/drawing/2014/main" id="{779B6871-424F-4659-9971-22414FA6BBC9}"/>
+                <a16:creationId xmlns:a16="http://schemas.microsoft.com/office/drawing/2014/main" id="{16E48F88-197F-4AC2-B627-C4D8EACDF397}"/>
               </a:ext>
             </a:extLst>
           </p:cNvPr>
@@ -2019,7 +2019,7 @@
           <p:cNvPr id="24" name="child-label">
             <a:extLst xmlns:a="http://schemas.openxmlformats.org/drawingml/2006/main">
               <a:ext uri="{FF2B5EF4-FFF2-40B4-BE49-F238E27FC236}">
-                <a16:creationId xmlns:a16="http://schemas.microsoft.com/office/drawing/2014/main" id="{BFEB9663-5481-4873-87E0-139D8502923E}"/>
+                <a16:creationId xmlns:a16="http://schemas.microsoft.com/office/drawing/2014/main" id="{172574AD-38EA-4EDE-90AB-F6ABE2FEB55D}"/>
               </a:ext>
             </a:extLst>
           </p:cNvPr>
@@ -2069,7 +2069,7 @@
           <p:cNvPr id="25" name="child-detail">
             <a:extLst xmlns:a="http://schemas.openxmlformats.org/drawingml/2006/main">
               <a:ext uri="{FF2B5EF4-FFF2-40B4-BE49-F238E27FC236}">
-                <a16:creationId xmlns:a16="http://schemas.microsoft.com/office/drawing/2014/main" id="{BA711549-C99A-456B-ACD4-53BBA6218159}"/>
+                <a16:creationId xmlns:a16="http://schemas.microsoft.com/office/drawing/2014/main" id="{0D9A27E7-F80B-4A0C-8F53-3301F0450480}"/>
               </a:ext>
             </a:extLst>
           </p:cNvPr>
@@ -2119,7 +2119,7 @@
           <p:cNvPr id="26" name="capture">
             <a:extLst xmlns:a="http://schemas.openxmlformats.org/drawingml/2006/main">
               <a:ext uri="{FF2B5EF4-FFF2-40B4-BE49-F238E27FC236}">
-                <a16:creationId xmlns:a16="http://schemas.microsoft.com/office/drawing/2014/main" id="{7652A7CB-99AF-4C63-A2F6-4AB504940B23}"/>
+                <a16:creationId xmlns:a16="http://schemas.microsoft.com/office/drawing/2014/main" id="{467E19BC-8D42-4516-9E3C-FBE41626D686}"/>
               </a:ext>
             </a:extLst>
           </p:cNvPr>
@@ -2154,7 +2154,7 @@
           <p:cNvPr id="27" name="capture-accent">
             <a:extLst xmlns:a="http://schemas.openxmlformats.org/drawingml/2006/main">
               <a:ext uri="{FF2B5EF4-FFF2-40B4-BE49-F238E27FC236}">
-                <a16:creationId xmlns:a16="http://schemas.microsoft.com/office/drawing/2014/main" id="{CBAE953E-C85F-46AC-95C9-F3AEA721D02A}"/>
+                <a16:creationId xmlns:a16="http://schemas.microsoft.com/office/drawing/2014/main" id="{059A2120-DEF6-487E-BF15-126394197C2E}"/>
               </a:ext>
             </a:extLst>
           </p:cNvPr>
@@ -2187,7 +2187,7 @@
           <p:cNvPr id="28" name="capture-label">
             <a:extLst xmlns:a="http://schemas.openxmlformats.org/drawingml/2006/main">
               <a:ext uri="{FF2B5EF4-FFF2-40B4-BE49-F238E27FC236}">
-                <a16:creationId xmlns:a16="http://schemas.microsoft.com/office/drawing/2014/main" id="{221DDE3A-C95A-4FBA-BB5C-D1E9DEE89EAD}"/>
+                <a16:creationId xmlns:a16="http://schemas.microsoft.com/office/drawing/2014/main" id="{C7CA6FFC-9AD9-44D4-9AD1-AAAFBF44E1CC}"/>
               </a:ext>
             </a:extLst>
           </p:cNvPr>
@@ -2237,7 +2237,7 @@
           <p:cNvPr id="29" name="capture-detail">
             <a:extLst xmlns:a="http://schemas.openxmlformats.org/drawingml/2006/main">
               <a:ext uri="{FF2B5EF4-FFF2-40B4-BE49-F238E27FC236}">
-                <a16:creationId xmlns:a16="http://schemas.microsoft.com/office/drawing/2014/main" id="{3C133E0B-391E-41A9-BA89-0E16FFAB07B1}"/>
+                <a16:creationId xmlns:a16="http://schemas.microsoft.com/office/drawing/2014/main" id="{74C70526-8658-4A3D-B47B-5DCFDF6926AE}"/>
               </a:ext>
             </a:extLst>
           </p:cNvPr>
@@ -2287,7 +2287,7 @@
           <p:cNvPr id="30" name="webui">
             <a:extLst xmlns:a="http://schemas.openxmlformats.org/drawingml/2006/main">
               <a:ext uri="{FF2B5EF4-FFF2-40B4-BE49-F238E27FC236}">
-                <a16:creationId xmlns:a16="http://schemas.microsoft.com/office/drawing/2014/main" id="{F767B96F-919D-46B1-9372-8DF4BCA72669}"/>
+                <a16:creationId xmlns:a16="http://schemas.microsoft.com/office/drawing/2014/main" id="{2BF1BA7A-1521-4A50-8129-8F46A2F59B4F}"/>
               </a:ext>
             </a:extLst>
           </p:cNvPr>
@@ -2322,7 +2322,7 @@
           <p:cNvPr id="31" name="webui-accent">
             <a:extLst xmlns:a="http://schemas.openxmlformats.org/drawingml/2006/main">
               <a:ext uri="{FF2B5EF4-FFF2-40B4-BE49-F238E27FC236}">
-                <a16:creationId xmlns:a16="http://schemas.microsoft.com/office/drawing/2014/main" id="{A4FCCB5D-987D-489D-87B5-B739C98DD0C2}"/>
+                <a16:creationId xmlns:a16="http://schemas.microsoft.com/office/drawing/2014/main" id="{3E4F7D23-0B32-4145-9AD0-034DD55B3430}"/>
               </a:ext>
             </a:extLst>
           </p:cNvPr>
@@ -2355,7 +2355,7 @@
           <p:cNvPr id="32" name="webui-label">
             <a:extLst xmlns:a="http://schemas.openxmlformats.org/drawingml/2006/main">
               <a:ext uri="{FF2B5EF4-FFF2-40B4-BE49-F238E27FC236}">
-                <a16:creationId xmlns:a16="http://schemas.microsoft.com/office/drawing/2014/main" id="{CB6F681D-126D-4B8D-86C4-42769263B077}"/>
+                <a16:creationId xmlns:a16="http://schemas.microsoft.com/office/drawing/2014/main" id="{64E307B8-E863-4A9A-A220-A5F41D51F2C5}"/>
               </a:ext>
             </a:extLst>
           </p:cNvPr>
@@ -2405,7 +2405,7 @@
           <p:cNvPr id="33" name="webui-detail">
             <a:extLst xmlns:a="http://schemas.openxmlformats.org/drawingml/2006/main">
               <a:ext uri="{FF2B5EF4-FFF2-40B4-BE49-F238E27FC236}">
-                <a16:creationId xmlns:a16="http://schemas.microsoft.com/office/drawing/2014/main" id="{10DD8C25-DC5D-4DD8-A63B-73E2FC00105F}"/>
+                <a16:creationId xmlns:a16="http://schemas.microsoft.com/office/drawing/2014/main" id="{E7ABE64F-4956-42BE-9B7D-02716EB847D2}"/>
               </a:ext>
             </a:extLst>
           </p:cNvPr>
@@ -2455,7 +2455,7 @@
           <p:cNvPr id="34" name="nodeapi">
             <a:extLst xmlns:a="http://schemas.openxmlformats.org/drawingml/2006/main">
               <a:ext uri="{FF2B5EF4-FFF2-40B4-BE49-F238E27FC236}">
-                <a16:creationId xmlns:a16="http://schemas.microsoft.com/office/drawing/2014/main" id="{772ED06E-E196-4386-8EFA-27B4902FEFC3}"/>
+                <a16:creationId xmlns:a16="http://schemas.microsoft.com/office/drawing/2014/main" id="{A245B351-7C46-460E-A38F-54811E277329}"/>
               </a:ext>
             </a:extLst>
           </p:cNvPr>
@@ -2490,7 +2490,7 @@
           <p:cNvPr id="35" name="nodeapi-accent">
             <a:extLst xmlns:a="http://schemas.openxmlformats.org/drawingml/2006/main">
               <a:ext uri="{FF2B5EF4-FFF2-40B4-BE49-F238E27FC236}">
-                <a16:creationId xmlns:a16="http://schemas.microsoft.com/office/drawing/2014/main" id="{BE96EF0C-7795-459D-B31D-1A8EFA05DC3A}"/>
+                <a16:creationId xmlns:a16="http://schemas.microsoft.com/office/drawing/2014/main" id="{F7FF6207-EB43-489C-9D18-833DE71623C3}"/>
               </a:ext>
             </a:extLst>
           </p:cNvPr>
@@ -2523,7 +2523,7 @@
           <p:cNvPr id="36" name="nodeapi-label">
             <a:extLst xmlns:a="http://schemas.openxmlformats.org/drawingml/2006/main">
               <a:ext uri="{FF2B5EF4-FFF2-40B4-BE49-F238E27FC236}">
-                <a16:creationId xmlns:a16="http://schemas.microsoft.com/office/drawing/2014/main" id="{E8AAE66E-9012-4FFA-9F3F-8AB5A4A749F8}"/>
+                <a16:creationId xmlns:a16="http://schemas.microsoft.com/office/drawing/2014/main" id="{1CAE2BF9-8F49-43AE-B700-721907487CF5}"/>
               </a:ext>
             </a:extLst>
           </p:cNvPr>
@@ -2590,7 +2590,7 @@
           <p:cNvPr id="37" name="router">
             <a:extLst xmlns:a="http://schemas.openxmlformats.org/drawingml/2006/main">
               <a:ext uri="{FF2B5EF4-FFF2-40B4-BE49-F238E27FC236}">
-                <a16:creationId xmlns:a16="http://schemas.microsoft.com/office/drawing/2014/main" id="{DC9A4A5E-919E-44DC-9E3E-EE4741C067E1}"/>
+                <a16:creationId xmlns:a16="http://schemas.microsoft.com/office/drawing/2014/main" id="{391B92E7-001D-481A-8C79-2062AC3851EA}"/>
               </a:ext>
             </a:extLst>
           </p:cNvPr>
@@ -2625,7 +2625,7 @@
           <p:cNvPr id="38" name="router-accent">
             <a:extLst xmlns:a="http://schemas.openxmlformats.org/drawingml/2006/main">
               <a:ext uri="{FF2B5EF4-FFF2-40B4-BE49-F238E27FC236}">
-                <a16:creationId xmlns:a16="http://schemas.microsoft.com/office/drawing/2014/main" id="{3034979B-D3D1-4D27-9EB5-F588E4AAD83A}"/>
+                <a16:creationId xmlns:a16="http://schemas.microsoft.com/office/drawing/2014/main" id="{A0DDE536-654D-48EC-B7DC-401561837480}"/>
               </a:ext>
             </a:extLst>
           </p:cNvPr>
@@ -2658,7 +2658,7 @@
           <p:cNvPr id="39" name="router-label">
             <a:extLst xmlns:a="http://schemas.openxmlformats.org/drawingml/2006/main">
               <a:ext uri="{FF2B5EF4-FFF2-40B4-BE49-F238E27FC236}">
-                <a16:creationId xmlns:a16="http://schemas.microsoft.com/office/drawing/2014/main" id="{C7055A3E-B0C8-4289-A920-A2E8D01B9481}"/>
+                <a16:creationId xmlns:a16="http://schemas.microsoft.com/office/drawing/2014/main" id="{0947A37C-5E73-4F72-88B5-C556968FE738}"/>
               </a:ext>
             </a:extLst>
           </p:cNvPr>
@@ -2708,7 +2708,7 @@
           <p:cNvPr id="40" name="router-detail">
             <a:extLst xmlns:a="http://schemas.openxmlformats.org/drawingml/2006/main">
               <a:ext uri="{FF2B5EF4-FFF2-40B4-BE49-F238E27FC236}">
-                <a16:creationId xmlns:a16="http://schemas.microsoft.com/office/drawing/2014/main" id="{767B053E-FCF3-4A37-A3F8-B5FC9FA64F66}"/>
+                <a16:creationId xmlns:a16="http://schemas.microsoft.com/office/drawing/2014/main" id="{7BE22B8E-019F-4845-886A-C4A41948B100}"/>
               </a:ext>
             </a:extLst>
           </p:cNvPr>
@@ -2758,7 +2758,7 @@
           <p:cNvPr id="41" name="profile-store">
             <a:extLst xmlns:a="http://schemas.openxmlformats.org/drawingml/2006/main">
               <a:ext uri="{FF2B5EF4-FFF2-40B4-BE49-F238E27FC236}">
-                <a16:creationId xmlns:a16="http://schemas.microsoft.com/office/drawing/2014/main" id="{3574BE42-7C90-4775-8CA5-00A4B6B3E9BB}"/>
+                <a16:creationId xmlns:a16="http://schemas.microsoft.com/office/drawing/2014/main" id="{143B537A-A689-4B9D-A0ED-B8812BCD38FA}"/>
               </a:ext>
             </a:extLst>
           </p:cNvPr>
@@ -2793,7 +2793,7 @@
           <p:cNvPr id="42" name="profile-store-accent">
             <a:extLst xmlns:a="http://schemas.openxmlformats.org/drawingml/2006/main">
               <a:ext uri="{FF2B5EF4-FFF2-40B4-BE49-F238E27FC236}">
-                <a16:creationId xmlns:a16="http://schemas.microsoft.com/office/drawing/2014/main" id="{833480F6-E9A9-452A-B191-BAA808CD71AB}"/>
+                <a16:creationId xmlns:a16="http://schemas.microsoft.com/office/drawing/2014/main" id="{ACAA947A-F26F-4718-B231-D15760D18CE1}"/>
               </a:ext>
             </a:extLst>
           </p:cNvPr>
@@ -2826,7 +2826,7 @@
           <p:cNvPr id="43" name="profile-store-label">
             <a:extLst xmlns:a="http://schemas.openxmlformats.org/drawingml/2006/main">
               <a:ext uri="{FF2B5EF4-FFF2-40B4-BE49-F238E27FC236}">
-                <a16:creationId xmlns:a16="http://schemas.microsoft.com/office/drawing/2014/main" id="{1ED029A8-3943-40E1-BBA2-6CACFE665995}"/>
+                <a16:creationId xmlns:a16="http://schemas.microsoft.com/office/drawing/2014/main" id="{10BE2C90-0C2B-4C1D-A0AD-B8BAB7B991AF}"/>
               </a:ext>
             </a:extLst>
           </p:cNvPr>
@@ -2876,7 +2876,7 @@
           <p:cNvPr id="44" name="profile-store-detail">
             <a:extLst xmlns:a="http://schemas.openxmlformats.org/drawingml/2006/main">
               <a:ext uri="{FF2B5EF4-FFF2-40B4-BE49-F238E27FC236}">
-                <a16:creationId xmlns:a16="http://schemas.microsoft.com/office/drawing/2014/main" id="{2E2098F8-7725-42F7-ACEE-7735EEE0156D}"/>
+                <a16:creationId xmlns:a16="http://schemas.microsoft.com/office/drawing/2014/main" id="{2529905C-34DF-4D8D-9A3D-08FE6DBE2C91}"/>
               </a:ext>
             </a:extLst>
           </p:cNvPr>
@@ -2916,7 +2916,7 @@
                   <a:srgbClr val="5D7180"/>
                 </a:solidFill>
               </a:rPr>
-              <a:t>写真・声サンプルを暗号化保存</a:t>
+              <a:t>写真・声・MP4を暗号化保存</a:t>
             </a:r>
           </a:p>
         </p:txBody>
@@ -2926,7 +2926,7 @@
           <p:cNvPr id="45" name="history-store">
             <a:extLst xmlns:a="http://schemas.openxmlformats.org/drawingml/2006/main">
               <a:ext uri="{FF2B5EF4-FFF2-40B4-BE49-F238E27FC236}">
-                <a16:creationId xmlns:a16="http://schemas.microsoft.com/office/drawing/2014/main" id="{D21DDD67-A22C-41CA-9BAA-ADF2690CC132}"/>
+                <a16:creationId xmlns:a16="http://schemas.microsoft.com/office/drawing/2014/main" id="{65F771F4-6049-4107-8B2F-91BC7E09FFE5}"/>
               </a:ext>
             </a:extLst>
           </p:cNvPr>
@@ -2961,7 +2961,7 @@
           <p:cNvPr id="46" name="history-store-accent">
             <a:extLst xmlns:a="http://schemas.openxmlformats.org/drawingml/2006/main">
               <a:ext uri="{FF2B5EF4-FFF2-40B4-BE49-F238E27FC236}">
-                <a16:creationId xmlns:a16="http://schemas.microsoft.com/office/drawing/2014/main" id="{4AC092A2-0D39-4B58-BFBF-401283C15E31}"/>
+                <a16:creationId xmlns:a16="http://schemas.microsoft.com/office/drawing/2014/main" id="{F71AD80B-F9F5-451D-BA0F-1206E2B69498}"/>
               </a:ext>
             </a:extLst>
           </p:cNvPr>
@@ -2994,7 +2994,7 @@
           <p:cNvPr id="47" name="history-store-label">
             <a:extLst xmlns:a="http://schemas.openxmlformats.org/drawingml/2006/main">
               <a:ext uri="{FF2B5EF4-FFF2-40B4-BE49-F238E27FC236}">
-                <a16:creationId xmlns:a16="http://schemas.microsoft.com/office/drawing/2014/main" id="{5D09A2A2-8FAD-401D-95DC-F25DF9EC21D6}"/>
+                <a16:creationId xmlns:a16="http://schemas.microsoft.com/office/drawing/2014/main" id="{3DCBC29F-35B8-4BD4-A146-5E8B3819234D}"/>
               </a:ext>
             </a:extLst>
           </p:cNvPr>
@@ -3044,7 +3044,7 @@
           <p:cNvPr id="48" name="history-store-detail">
             <a:extLst xmlns:a="http://schemas.openxmlformats.org/drawingml/2006/main">
               <a:ext uri="{FF2B5EF4-FFF2-40B4-BE49-F238E27FC236}">
-                <a16:creationId xmlns:a16="http://schemas.microsoft.com/office/drawing/2014/main" id="{38EEE2C9-2791-4453-955B-6B2CC21C6FC0}"/>
+                <a16:creationId xmlns:a16="http://schemas.microsoft.com/office/drawing/2014/main" id="{E786970E-93D2-4285-AAFB-26B159051647}"/>
               </a:ext>
             </a:extLst>
           </p:cNvPr>
@@ -3111,7 +3111,7 @@
           <p:cNvPr id="49" name="decision-region">
             <a:extLst xmlns:a="http://schemas.openxmlformats.org/drawingml/2006/main">
               <a:ext uri="{FF2B5EF4-FFF2-40B4-BE49-F238E27FC236}">
-                <a16:creationId xmlns:a16="http://schemas.microsoft.com/office/drawing/2014/main" id="{22231807-9ED6-434B-8BFD-05EF94D86AFC}"/>
+                <a16:creationId xmlns:a16="http://schemas.microsoft.com/office/drawing/2014/main" id="{DF7727EC-DBD3-4422-9755-5E6A292C136F}"/>
               </a:ext>
             </a:extLst>
           </p:cNvPr>
@@ -3144,7 +3144,7 @@
           <p:cNvPr id="50" name="decision-region-label">
             <a:extLst xmlns:a="http://schemas.openxmlformats.org/drawingml/2006/main">
               <a:ext uri="{FF2B5EF4-FFF2-40B4-BE49-F238E27FC236}">
-                <a16:creationId xmlns:a16="http://schemas.microsoft.com/office/drawing/2014/main" id="{6A43A08D-8B84-41F6-9BD3-E950B6CBE466}"/>
+                <a16:creationId xmlns:a16="http://schemas.microsoft.com/office/drawing/2014/main" id="{7832FAFB-8457-42A9-A748-B1D1ECACFF63}"/>
               </a:ext>
             </a:extLst>
           </p:cNvPr>
@@ -3194,7 +3194,7 @@
           <p:cNvPr id="51" name="normal">
             <a:extLst xmlns:a="http://schemas.openxmlformats.org/drawingml/2006/main">
               <a:ext uri="{FF2B5EF4-FFF2-40B4-BE49-F238E27FC236}">
-                <a16:creationId xmlns:a16="http://schemas.microsoft.com/office/drawing/2014/main" id="{9B5C6CEB-BED1-406B-B61A-5A2A076F05A0}"/>
+                <a16:creationId xmlns:a16="http://schemas.microsoft.com/office/drawing/2014/main" id="{6219260E-1379-408A-BEE4-F8873909701E}"/>
               </a:ext>
             </a:extLst>
           </p:cNvPr>
@@ -3229,7 +3229,7 @@
           <p:cNvPr id="52" name="normal-accent">
             <a:extLst xmlns:a="http://schemas.openxmlformats.org/drawingml/2006/main">
               <a:ext uri="{FF2B5EF4-FFF2-40B4-BE49-F238E27FC236}">
-                <a16:creationId xmlns:a16="http://schemas.microsoft.com/office/drawing/2014/main" id="{5D46918F-7618-4884-8419-39EDF2F475FB}"/>
+                <a16:creationId xmlns:a16="http://schemas.microsoft.com/office/drawing/2014/main" id="{50B9FF7E-7CA0-42E3-B679-BA38ACCE2F83}"/>
               </a:ext>
             </a:extLst>
           </p:cNvPr>
@@ -3262,7 +3262,7 @@
           <p:cNvPr id="53" name="normal-label">
             <a:extLst xmlns:a="http://schemas.openxmlformats.org/drawingml/2006/main">
               <a:ext uri="{FF2B5EF4-FFF2-40B4-BE49-F238E27FC236}">
-                <a16:creationId xmlns:a16="http://schemas.microsoft.com/office/drawing/2014/main" id="{5FA9A457-F903-4B62-96A0-3C364FD7A553}"/>
+                <a16:creationId xmlns:a16="http://schemas.microsoft.com/office/drawing/2014/main" id="{FEBF3A96-7A34-47DE-9DF1-670580069673}"/>
               </a:ext>
             </a:extLst>
           </p:cNvPr>
@@ -3312,7 +3312,7 @@
           <p:cNvPr id="54" name="care">
             <a:extLst xmlns:a="http://schemas.openxmlformats.org/drawingml/2006/main">
               <a:ext uri="{FF2B5EF4-FFF2-40B4-BE49-F238E27FC236}">
-                <a16:creationId xmlns:a16="http://schemas.microsoft.com/office/drawing/2014/main" id="{B06E77BD-734C-4CBC-8FBC-B39244FA44EF}"/>
+                <a16:creationId xmlns:a16="http://schemas.microsoft.com/office/drawing/2014/main" id="{D2E8BE0F-C811-489C-87F8-FECEA03EE7CD}"/>
               </a:ext>
             </a:extLst>
           </p:cNvPr>
@@ -3347,7 +3347,7 @@
           <p:cNvPr id="55" name="care-accent">
             <a:extLst xmlns:a="http://schemas.openxmlformats.org/drawingml/2006/main">
               <a:ext uri="{FF2B5EF4-FFF2-40B4-BE49-F238E27FC236}">
-                <a16:creationId xmlns:a16="http://schemas.microsoft.com/office/drawing/2014/main" id="{AC75E92E-DA96-4E0F-B486-3AF9CF378C10}"/>
+                <a16:creationId xmlns:a16="http://schemas.microsoft.com/office/drawing/2014/main" id="{3D13321F-A929-4FA4-ADAD-255701E561A3}"/>
               </a:ext>
             </a:extLst>
           </p:cNvPr>
@@ -3380,7 +3380,7 @@
           <p:cNvPr id="56" name="care-label">
             <a:extLst xmlns:a="http://schemas.openxmlformats.org/drawingml/2006/main">
               <a:ext uri="{FF2B5EF4-FFF2-40B4-BE49-F238E27FC236}">
-                <a16:creationId xmlns:a16="http://schemas.microsoft.com/office/drawing/2014/main" id="{0BFA97B5-57F5-4734-902D-45A428F4E86F}"/>
+                <a16:creationId xmlns:a16="http://schemas.microsoft.com/office/drawing/2014/main" id="{14AC8CED-760D-43B9-88C4-B59751AE11B4}"/>
               </a:ext>
             </a:extLst>
           </p:cNvPr>
@@ -3430,7 +3430,7 @@
           <p:cNvPr id="57" name="safety">
             <a:extLst xmlns:a="http://schemas.openxmlformats.org/drawingml/2006/main">
               <a:ext uri="{FF2B5EF4-FFF2-40B4-BE49-F238E27FC236}">
-                <a16:creationId xmlns:a16="http://schemas.microsoft.com/office/drawing/2014/main" id="{8FE1B17B-1F07-4AA2-A8EA-98F71CDEE854}"/>
+                <a16:creationId xmlns:a16="http://schemas.microsoft.com/office/drawing/2014/main" id="{F285E797-0D0A-4F40-B47B-FF9418104859}"/>
               </a:ext>
             </a:extLst>
           </p:cNvPr>
@@ -3465,7 +3465,7 @@
           <p:cNvPr id="58" name="safety-accent">
             <a:extLst xmlns:a="http://schemas.openxmlformats.org/drawingml/2006/main">
               <a:ext uri="{FF2B5EF4-FFF2-40B4-BE49-F238E27FC236}">
-                <a16:creationId xmlns:a16="http://schemas.microsoft.com/office/drawing/2014/main" id="{E4E0D534-FDB8-4DF3-B813-B56F77EE9A7A}"/>
+                <a16:creationId xmlns:a16="http://schemas.microsoft.com/office/drawing/2014/main" id="{29845DCF-49F2-4D44-A918-016117E5A76D}"/>
               </a:ext>
             </a:extLst>
           </p:cNvPr>
@@ -3498,7 +3498,7 @@
           <p:cNvPr id="59" name="safety-label">
             <a:extLst xmlns:a="http://schemas.openxmlformats.org/drawingml/2006/main">
               <a:ext uri="{FF2B5EF4-FFF2-40B4-BE49-F238E27FC236}">
-                <a16:creationId xmlns:a16="http://schemas.microsoft.com/office/drawing/2014/main" id="{F6059881-07CF-4829-B3E9-F4045A4FE05D}"/>
+                <a16:creationId xmlns:a16="http://schemas.microsoft.com/office/drawing/2014/main" id="{D5746BE8-CC78-4AE5-8F17-BCB2ACE688A0}"/>
               </a:ext>
             </a:extLst>
           </p:cNvPr>
@@ -3548,7 +3548,7 @@
           <p:cNvPr id="60" name="bundle-region">
             <a:extLst xmlns:a="http://schemas.openxmlformats.org/drawingml/2006/main">
               <a:ext uri="{FF2B5EF4-FFF2-40B4-BE49-F238E27FC236}">
-                <a16:creationId xmlns:a16="http://schemas.microsoft.com/office/drawing/2014/main" id="{E2039E96-A726-4CFF-BC6D-B2D17BE2AF83}"/>
+                <a16:creationId xmlns:a16="http://schemas.microsoft.com/office/drawing/2014/main" id="{ECB04EF9-56E3-4AD4-AF2A-91311D80AF9C}"/>
               </a:ext>
             </a:extLst>
           </p:cNvPr>
@@ -3581,7 +3581,7 @@
           <p:cNvPr id="61" name="bundle-region-label">
             <a:extLst xmlns:a="http://schemas.openxmlformats.org/drawingml/2006/main">
               <a:ext uri="{FF2B5EF4-FFF2-40B4-BE49-F238E27FC236}">
-                <a16:creationId xmlns:a16="http://schemas.microsoft.com/office/drawing/2014/main" id="{D1F4625F-63C4-48AA-BB93-01FFBF7111C5}"/>
+                <a16:creationId xmlns:a16="http://schemas.microsoft.com/office/drawing/2014/main" id="{DF2E898B-D17E-4037-8986-88DCCC689673}"/>
               </a:ext>
             </a:extLst>
           </p:cNvPr>
@@ -3631,7 +3631,7 @@
           <p:cNvPr id="62" name="replytext">
             <a:extLst xmlns:a="http://schemas.openxmlformats.org/drawingml/2006/main">
               <a:ext uri="{FF2B5EF4-FFF2-40B4-BE49-F238E27FC236}">
-                <a16:creationId xmlns:a16="http://schemas.microsoft.com/office/drawing/2014/main" id="{8DAD7321-A752-421E-B17C-F3108807737D}"/>
+                <a16:creationId xmlns:a16="http://schemas.microsoft.com/office/drawing/2014/main" id="{1DA07E6D-0F51-4274-B8A3-855E6D843F63}"/>
               </a:ext>
             </a:extLst>
           </p:cNvPr>
@@ -3666,7 +3666,7 @@
           <p:cNvPr id="63" name="replytext-accent">
             <a:extLst xmlns:a="http://schemas.openxmlformats.org/drawingml/2006/main">
               <a:ext uri="{FF2B5EF4-FFF2-40B4-BE49-F238E27FC236}">
-                <a16:creationId xmlns:a16="http://schemas.microsoft.com/office/drawing/2014/main" id="{E2C75EC3-22A4-44B8-8C68-966AC57F09D2}"/>
+                <a16:creationId xmlns:a16="http://schemas.microsoft.com/office/drawing/2014/main" id="{ED313462-971E-4C37-9235-5AA0506FB1C4}"/>
               </a:ext>
             </a:extLst>
           </p:cNvPr>
@@ -3699,7 +3699,7 @@
           <p:cNvPr id="64" name="replytext-label">
             <a:extLst xmlns:a="http://schemas.openxmlformats.org/drawingml/2006/main">
               <a:ext uri="{FF2B5EF4-FFF2-40B4-BE49-F238E27FC236}">
-                <a16:creationId xmlns:a16="http://schemas.microsoft.com/office/drawing/2014/main" id="{A0A4B172-4D1A-4579-BDFC-0F1D40B66FF6}"/>
+                <a16:creationId xmlns:a16="http://schemas.microsoft.com/office/drawing/2014/main" id="{DE4EE4FF-4681-4D98-A5A0-458F7596A642}"/>
               </a:ext>
             </a:extLst>
           </p:cNvPr>
@@ -3749,7 +3749,7 @@
           <p:cNvPr id="65" name="replytext-detail">
             <a:extLst xmlns:a="http://schemas.openxmlformats.org/drawingml/2006/main">
               <a:ext uri="{FF2B5EF4-FFF2-40B4-BE49-F238E27FC236}">
-                <a16:creationId xmlns:a16="http://schemas.microsoft.com/office/drawing/2014/main" id="{0C7A0F6F-4E9E-45DB-AD59-E12E7C6D7788}"/>
+                <a16:creationId xmlns:a16="http://schemas.microsoft.com/office/drawing/2014/main" id="{ADE45D59-E038-4FF5-81FC-F5875210573D}"/>
               </a:ext>
             </a:extLst>
           </p:cNvPr>
@@ -3799,7 +3799,7 @@
           <p:cNvPr id="66" name="photo">
             <a:extLst xmlns:a="http://schemas.openxmlformats.org/drawingml/2006/main">
               <a:ext uri="{FF2B5EF4-FFF2-40B4-BE49-F238E27FC236}">
-                <a16:creationId xmlns:a16="http://schemas.microsoft.com/office/drawing/2014/main" id="{56F525F8-30D2-4089-831A-578BE79EF11D}"/>
+                <a16:creationId xmlns:a16="http://schemas.microsoft.com/office/drawing/2014/main" id="{7B724F57-A554-4B4E-9337-044D0EE496A4}"/>
               </a:ext>
             </a:extLst>
           </p:cNvPr>
@@ -3834,7 +3834,7 @@
           <p:cNvPr id="67" name="photo-accent">
             <a:extLst xmlns:a="http://schemas.openxmlformats.org/drawingml/2006/main">
               <a:ext uri="{FF2B5EF4-FFF2-40B4-BE49-F238E27FC236}">
-                <a16:creationId xmlns:a16="http://schemas.microsoft.com/office/drawing/2014/main" id="{DE924CD8-DC54-49F5-8406-C9228F021FA0}"/>
+                <a16:creationId xmlns:a16="http://schemas.microsoft.com/office/drawing/2014/main" id="{6BFFEB24-3202-4FF2-9356-88AB0561CA5B}"/>
               </a:ext>
             </a:extLst>
           </p:cNvPr>
@@ -3867,7 +3867,7 @@
           <p:cNvPr id="68" name="photo-label">
             <a:extLst xmlns:a="http://schemas.openxmlformats.org/drawingml/2006/main">
               <a:ext uri="{FF2B5EF4-FFF2-40B4-BE49-F238E27FC236}">
-                <a16:creationId xmlns:a16="http://schemas.microsoft.com/office/drawing/2014/main" id="{7A44944C-1E0F-44CA-897A-67FB7BFC9E42}"/>
+                <a16:creationId xmlns:a16="http://schemas.microsoft.com/office/drawing/2014/main" id="{E208885E-774C-4BB3-B865-667404D858A7}"/>
               </a:ext>
             </a:extLst>
           </p:cNvPr>
@@ -3907,7 +3907,7 @@
                   <a:srgbClr val="172B3A"/>
                 </a:solidFill>
               </a:rPr>
-              <a:t>登録親写真</a:t>
+              <a:t>生成親動画</a:t>
             </a:r>
           </a:p>
         </p:txBody>
@@ -3917,7 +3917,7 @@
           <p:cNvPr id="69" name="photo-detail">
             <a:extLst xmlns:a="http://schemas.openxmlformats.org/drawingml/2006/main">
               <a:ext uri="{FF2B5EF4-FFF2-40B4-BE49-F238E27FC236}">
-                <a16:creationId xmlns:a16="http://schemas.microsoft.com/office/drawing/2014/main" id="{F813B5AB-2299-4B18-AF9A-2EA58D528401}"/>
+                <a16:creationId xmlns:a16="http://schemas.microsoft.com/office/drawing/2014/main" id="{8E36A8F6-58E4-4BF2-A094-47C0DDF355F7}"/>
               </a:ext>
             </a:extLst>
           </p:cNvPr>
@@ -3957,7 +3957,7 @@
                   <a:srgbClr val="5D7180"/>
                 </a:solidFill>
               </a:rPr>
-              <a:t>音声中に簡易アニメ</a:t>
+              <a:t>Kling MP4をループ</a:t>
             </a:r>
           </a:p>
         </p:txBody>
@@ -3967,7 +3967,7 @@
           <p:cNvPr id="70" name="tts">
             <a:extLst xmlns:a="http://schemas.openxmlformats.org/drawingml/2006/main">
               <a:ext uri="{FF2B5EF4-FFF2-40B4-BE49-F238E27FC236}">
-                <a16:creationId xmlns:a16="http://schemas.microsoft.com/office/drawing/2014/main" id="{3FFA7D53-599D-4F20-A5B4-4866990E67CA}"/>
+                <a16:creationId xmlns:a16="http://schemas.microsoft.com/office/drawing/2014/main" id="{253C021B-ED86-4313-955B-DBE74B36134A}"/>
               </a:ext>
             </a:extLst>
           </p:cNvPr>
@@ -4002,7 +4002,7 @@
           <p:cNvPr id="71" name="tts-accent">
             <a:extLst xmlns:a="http://schemas.openxmlformats.org/drawingml/2006/main">
               <a:ext uri="{FF2B5EF4-FFF2-40B4-BE49-F238E27FC236}">
-                <a16:creationId xmlns:a16="http://schemas.microsoft.com/office/drawing/2014/main" id="{C56CB28F-5C9B-4760-A906-28A9F5361689}"/>
+                <a16:creationId xmlns:a16="http://schemas.microsoft.com/office/drawing/2014/main" id="{E03F60FB-AD97-479D-A3CD-EC7DFFA12ED8}"/>
               </a:ext>
             </a:extLst>
           </p:cNvPr>
@@ -4035,7 +4035,7 @@
           <p:cNvPr id="72" name="tts-label">
             <a:extLst xmlns:a="http://schemas.openxmlformats.org/drawingml/2006/main">
               <a:ext uri="{FF2B5EF4-FFF2-40B4-BE49-F238E27FC236}">
-                <a16:creationId xmlns:a16="http://schemas.microsoft.com/office/drawing/2014/main" id="{FACB22DA-C6DA-49A0-A09E-813EB11937E8}"/>
+                <a16:creationId xmlns:a16="http://schemas.microsoft.com/office/drawing/2014/main" id="{46FE6245-B0D8-47D5-856A-107508B3EA89}"/>
               </a:ext>
             </a:extLst>
           </p:cNvPr>
@@ -4085,7 +4085,7 @@
           <p:cNvPr id="73" name="tts-detail">
             <a:extLst xmlns:a="http://schemas.openxmlformats.org/drawingml/2006/main">
               <a:ext uri="{FF2B5EF4-FFF2-40B4-BE49-F238E27FC236}">
-                <a16:creationId xmlns:a16="http://schemas.microsoft.com/office/drawing/2014/main" id="{6C1D070F-7378-44D3-BF48-46E27F9E82C9}"/>
+                <a16:creationId xmlns:a16="http://schemas.microsoft.com/office/drawing/2014/main" id="{5CEE0C9A-8BD1-4C69-A490-21EF9A4BD4A5}"/>
               </a:ext>
             </a:extLst>
           </p:cNvPr>
@@ -4125,7 +4125,7 @@
                   <a:srgbClr val="5D7180"/>
                 </a:solidFill>
               </a:rPr>
-              <a:t>動的読み上げ</a:t>
+              <a:t>返答ごとに生成</a:t>
             </a:r>
           </a:p>
           <a:p xmlns:a="http://schemas.openxmlformats.org/drawingml/2006/main">
@@ -4142,7 +4142,7 @@
                   <a:srgbClr val="5D7180"/>
                 </a:solidFill>
               </a:rPr>
-              <a:t>音声URL再生</a:t>
+              <a:t>その場で読み上げ</a:t>
             </a:r>
           </a:p>
         </p:txBody>
@@ -4152,7 +4152,7 @@
           <p:cNvPr id="74" name="present">
             <a:extLst xmlns:a="http://schemas.openxmlformats.org/drawingml/2006/main">
               <a:ext uri="{FF2B5EF4-FFF2-40B4-BE49-F238E27FC236}">
-                <a16:creationId xmlns:a16="http://schemas.microsoft.com/office/drawing/2014/main" id="{CBB0D31D-9713-4AFC-B8BA-118F96CDF4EB}"/>
+                <a16:creationId xmlns:a16="http://schemas.microsoft.com/office/drawing/2014/main" id="{5ABDF3E2-8C83-444C-BAD3-BBCBB72C061B}"/>
               </a:ext>
             </a:extLst>
           </p:cNvPr>
@@ -4187,7 +4187,7 @@
           <p:cNvPr id="75" name="present-accent">
             <a:extLst xmlns:a="http://schemas.openxmlformats.org/drawingml/2006/main">
               <a:ext uri="{FF2B5EF4-FFF2-40B4-BE49-F238E27FC236}">
-                <a16:creationId xmlns:a16="http://schemas.microsoft.com/office/drawing/2014/main" id="{F09BCB36-3756-41AB-B5E7-1FF69C9C92D4}"/>
+                <a16:creationId xmlns:a16="http://schemas.microsoft.com/office/drawing/2014/main" id="{9FCCAFEF-3359-4F0F-BAF0-DD66F2BFF623}"/>
               </a:ext>
             </a:extLst>
           </p:cNvPr>
@@ -4220,7 +4220,7 @@
           <p:cNvPr id="76" name="present-label">
             <a:extLst xmlns:a="http://schemas.openxmlformats.org/drawingml/2006/main">
               <a:ext uri="{FF2B5EF4-FFF2-40B4-BE49-F238E27FC236}">
-                <a16:creationId xmlns:a16="http://schemas.microsoft.com/office/drawing/2014/main" id="{184DC380-2785-4EBB-83BC-580E698DFE95}"/>
+                <a16:creationId xmlns:a16="http://schemas.microsoft.com/office/drawing/2014/main" id="{21CD6AEF-D61D-4B63-AE8D-7C8D2F9F300F}"/>
               </a:ext>
             </a:extLst>
           </p:cNvPr>
@@ -4270,7 +4270,7 @@
           <p:cNvPr id="77" name="present-detail">
             <a:extLst xmlns:a="http://schemas.openxmlformats.org/drawingml/2006/main">
               <a:ext uri="{FF2B5EF4-FFF2-40B4-BE49-F238E27FC236}">
-                <a16:creationId xmlns:a16="http://schemas.microsoft.com/office/drawing/2014/main" id="{3A5C5DE2-FE35-455A-9BC3-6D83F962F7C2}"/>
+                <a16:creationId xmlns:a16="http://schemas.microsoft.com/office/drawing/2014/main" id="{59FA07EE-7947-46F9-AD4C-46F7ED49B941}"/>
               </a:ext>
             </a:extLst>
           </p:cNvPr>
@@ -4310,7 +4310,7 @@
                   <a:srgbClr val="5D7180"/>
                 </a:solidFill>
               </a:rPr>
-              <a:t>字幕 ＋ 写真 ＋ 音声</a:t>
+              <a:t>字幕 ＋ 動画 ＋ 音声</a:t>
             </a:r>
           </a:p>
         </p:txBody>
@@ -4320,7 +4320,7 @@
           <p:cNvPr id="78" name="simultaneous-note">
             <a:extLst xmlns:a="http://schemas.openxmlformats.org/drawingml/2006/main">
               <a:ext uri="{FF2B5EF4-FFF2-40B4-BE49-F238E27FC236}">
-                <a16:creationId xmlns:a16="http://schemas.microsoft.com/office/drawing/2014/main" id="{D031EA73-75F0-49EE-8D3A-64D5E41CD3DB}"/>
+                <a16:creationId xmlns:a16="http://schemas.microsoft.com/office/drawing/2014/main" id="{1D88A686-77E1-4F4F-937F-6CB0C753EFDF}"/>
               </a:ext>
             </a:extLst>
           </p:cNvPr>
@@ -4370,7 +4370,7 @@
           <p:cNvPr id="79" name="footer1">
             <a:extLst xmlns:a="http://schemas.openxmlformats.org/drawingml/2006/main">
               <a:ext uri="{FF2B5EF4-FFF2-40B4-BE49-F238E27FC236}">
-                <a16:creationId xmlns:a16="http://schemas.microsoft.com/office/drawing/2014/main" id="{44639AAC-018A-4C01-8668-BBBE5C8C44E9}"/>
+                <a16:creationId xmlns:a16="http://schemas.microsoft.com/office/drawing/2014/main" id="{47E5BE6B-716A-489F-BCA8-44EC6FE857BB}"/>
               </a:ext>
             </a:extLst>
           </p:cNvPr>
@@ -4420,7 +4420,7 @@
           <p:cNvPr id="80" name="">
             <a:extLst xmlns:a="http://schemas.openxmlformats.org/drawingml/2006/main">
               <a:ext uri="{FF2B5EF4-FFF2-40B4-BE49-F238E27FC236}">
-                <a16:creationId xmlns:a16="http://schemas.microsoft.com/office/drawing/2014/main" id="{37915D77-63C1-4F52-82E1-CA7CEBD03031}"/>
+                <a16:creationId xmlns:a16="http://schemas.microsoft.com/office/drawing/2014/main" id="{83696988-C7FB-4A56-BD6A-1D6C9EE82A39}"/>
               </a:ext>
             </a:extLst>
           </p:cNvPr>
@@ -4451,7 +4451,7 @@
           <p:cNvPr id="81" name="legend-実装済み">
             <a:extLst xmlns:a="http://schemas.openxmlformats.org/drawingml/2006/main">
               <a:ext uri="{FF2B5EF4-FFF2-40B4-BE49-F238E27FC236}">
-                <a16:creationId xmlns:a16="http://schemas.microsoft.com/office/drawing/2014/main" id="{3F8A1271-7766-477E-8BF2-74C125738761}"/>
+                <a16:creationId xmlns:a16="http://schemas.microsoft.com/office/drawing/2014/main" id="{D147AE76-779B-451A-9DC3-9A7B2D52DED3}"/>
               </a:ext>
             </a:extLst>
           </p:cNvPr>
@@ -4499,7 +4499,7 @@
     </p:spTree>
     <p:extLst>
       <p:ext uri="{BB962C8B-B14F-4D97-AF65-F5344CB8AC3E}">
-        <p14:creationId xmlns:p14="http://schemas.microsoft.com/office/powerpoint/2010/main" val="477234335"/>
+        <p14:creationId xmlns:p14="http://schemas.microsoft.com/office/powerpoint/2010/main" val="1239273824"/>
       </p:ext>
     </p:extLst>
   </p:cSld>
@@ -4530,7 +4530,7 @@
           <p:cNvPr id="67" name="slide-2-title">
             <a:extLst xmlns:a="http://schemas.openxmlformats.org/drawingml/2006/main">
               <a:ext uri="{FF2B5EF4-FFF2-40B4-BE49-F238E27FC236}">
-                <a16:creationId xmlns:a16="http://schemas.microsoft.com/office/drawing/2014/main" id="{FE618899-25EF-4423-806B-0856D3B632EA}"/>
+                <a16:creationId xmlns:a16="http://schemas.microsoft.com/office/drawing/2014/main" id="{97D2F679-70CE-4EC0-8D11-3E7E3C327FBD}"/>
               </a:ext>
             </a:extLst>
           </p:cNvPr>
@@ -4570,7 +4570,7 @@
                   <a:srgbClr val="172B3A"/>
                 </a:solidFill>
               </a:rPr>
-              <a:t>OrcaRouter経由で音声・動画モデルを追加</a:t>
+              <a:t>登録時に実動画を作り、会話では待たずに再利用</a:t>
             </a:r>
           </a:p>
         </p:txBody>
@@ -4580,7 +4580,7 @@
           <p:cNvPr id="2" name="slide-2-subtitle">
             <a:extLst xmlns:a="http://schemas.openxmlformats.org/drawingml/2006/main">
               <a:ext uri="{FF2B5EF4-FFF2-40B4-BE49-F238E27FC236}">
-                <a16:creationId xmlns:a16="http://schemas.microsoft.com/office/drawing/2014/main" id="{51DA80D3-BBD4-4F7C-AB97-BE3710017CE9}"/>
+                <a16:creationId xmlns:a16="http://schemas.microsoft.com/office/drawing/2014/main" id="{2740EE51-065F-42D5-BE11-41015CB9E96D}"/>
               </a:ext>
             </a:extLst>
           </p:cNvPr>
@@ -4620,7 +4620,7 @@
                   <a:srgbClr val="5D7180"/>
                 </a:solidFill>
               </a:rPr>
-              <a:t>ゲートウェイから同期TTSと非同期動画へ。リアルタイム会話は待たない</a:t>
+              <a:t>OrcaRouterからKlingへ非同期生成。完成MP4を保存し、返答時にすぐ再生</a:t>
             </a:r>
           </a:p>
         </p:txBody>
@@ -4630,7 +4630,7 @@
           <p:cNvPr id="3" name="slide-2-number">
             <a:extLst xmlns:a="http://schemas.openxmlformats.org/drawingml/2006/main">
               <a:ext uri="{FF2B5EF4-FFF2-40B4-BE49-F238E27FC236}">
-                <a16:creationId xmlns:a16="http://schemas.microsoft.com/office/drawing/2014/main" id="{F05DAFBB-ECC1-4363-ABA8-4C3EE3450395}"/>
+                <a16:creationId xmlns:a16="http://schemas.microsoft.com/office/drawing/2014/main" id="{BBDA849A-D722-4260-B08B-87D654440DE2}"/>
               </a:ext>
             </a:extLst>
           </p:cNvPr>
@@ -4680,7 +4680,7 @@
           <p:cNvPr id="4" name="implemented-region">
             <a:extLst xmlns:a="http://schemas.openxmlformats.org/drawingml/2006/main">
               <a:ext uri="{FF2B5EF4-FFF2-40B4-BE49-F238E27FC236}">
-                <a16:creationId xmlns:a16="http://schemas.microsoft.com/office/drawing/2014/main" id="{D4C8BCE8-448C-4134-B852-AAC89C99BB08}"/>
+                <a16:creationId xmlns:a16="http://schemas.microsoft.com/office/drawing/2014/main" id="{C533B9D0-AFAA-4C52-A025-A65A61DBEDFC}"/>
               </a:ext>
             </a:extLst>
           </p:cNvPr>
@@ -4713,7 +4713,7 @@
           <p:cNvPr id="5" name="implemented-region-label">
             <a:extLst xmlns:a="http://schemas.openxmlformats.org/drawingml/2006/main">
               <a:ext uri="{FF2B5EF4-FFF2-40B4-BE49-F238E27FC236}">
-                <a16:creationId xmlns:a16="http://schemas.microsoft.com/office/drawing/2014/main" id="{4CB688C6-A149-4C2D-B6B2-C8861B61C9C9}"/>
+                <a16:creationId xmlns:a16="http://schemas.microsoft.com/office/drawing/2014/main" id="{5873BBC7-216F-4CD3-8B50-50F377CB8890}"/>
               </a:ext>
             </a:extLst>
           </p:cNvPr>
@@ -4753,7 +4753,7 @@
                   <a:srgbClr val="147EBA"/>
                 </a:solidFill>
               </a:rPr>
-              <a:t>リアルタイム会話（実装済み）</a:t>
+              <a:t>会話経路（実装済み）</a:t>
             </a:r>
           </a:p>
         </p:txBody>
@@ -4763,7 +4763,7 @@
           <p:cNvPr id="6" name="future-region">
             <a:extLst xmlns:a="http://schemas.openxmlformats.org/drawingml/2006/main">
               <a:ext uri="{FF2B5EF4-FFF2-40B4-BE49-F238E27FC236}">
-                <a16:creationId xmlns:a16="http://schemas.microsoft.com/office/drawing/2014/main" id="{049E19F1-B1F8-4856-81C1-6AC59330338E}"/>
+                <a16:creationId xmlns:a16="http://schemas.microsoft.com/office/drawing/2014/main" id="{26858DCC-85CA-4BEA-8814-92A14B1F2EE1}"/>
               </a:ext>
             </a:extLst>
           </p:cNvPr>
@@ -4785,7 +4785,7 @@
           </a:solidFill>
           <a:ln xmlns:a="http://schemas.openxmlformats.org/drawingml/2006/main" w="15240">
             <a:solidFill>
-              <a:srgbClr val="F38B2A"/>
+              <a:srgbClr val="147EBA"/>
             </a:solidFill>
             <a:prstDash val="dash"/>
           </a:ln>
@@ -4796,7 +4796,7 @@
           <p:cNvPr id="7" name="future-region-label">
             <a:extLst xmlns:a="http://schemas.openxmlformats.org/drawingml/2006/main">
               <a:ext uri="{FF2B5EF4-FFF2-40B4-BE49-F238E27FC236}">
-                <a16:creationId xmlns:a16="http://schemas.microsoft.com/office/drawing/2014/main" id="{546EBCEC-E0CD-4A9A-A86A-718441ACF511}"/>
+                <a16:creationId xmlns:a16="http://schemas.microsoft.com/office/drawing/2014/main" id="{D9B23D2E-686C-4939-9303-C95FC015FA27}"/>
               </a:ext>
             </a:extLst>
           </p:cNvPr>
@@ -4826,17 +4826,17 @@
             <a:pPr algn="l">
               <a:defRPr sz="1350" b="1">
                 <a:solidFill>
-                  <a:srgbClr val="F38B2A"/>
+                  <a:srgbClr val="147EBA"/>
                 </a:solidFill>
               </a:defRPr>
             </a:pPr>
             <a:r>
               <a:rPr sz="1350" b="1">
                 <a:solidFill>
-                  <a:srgbClr val="F38B2A"/>
+                  <a:srgbClr val="147EBA"/>
                 </a:solidFill>
               </a:rPr>
-              <a:t>次に追加（破線）</a:t>
+              <a:t>外部連携・生成保存</a:t>
             </a:r>
           </a:p>
         </p:txBody>
@@ -4846,7 +4846,7 @@
           <p:cNvPr id="8" name="s2-current-a">
             <a:extLst xmlns:a="http://schemas.openxmlformats.org/drawingml/2006/main">
               <a:ext uri="{FF2B5EF4-FFF2-40B4-BE49-F238E27FC236}">
-                <a16:creationId xmlns:a16="http://schemas.microsoft.com/office/drawing/2014/main" id="{9BDDAD26-E0FF-4A1E-86E4-819DD1E2101B}"/>
+                <a16:creationId xmlns:a16="http://schemas.microsoft.com/office/drawing/2014/main" id="{545B1B99-E0F5-4D79-BED7-D7931C867A48}"/>
               </a:ext>
             </a:extLst>
           </p:cNvPr>
@@ -4877,7 +4877,7 @@
           <p:cNvPr id="9" name="s2-current-a-head">
             <a:extLst xmlns:a="http://schemas.openxmlformats.org/drawingml/2006/main">
               <a:ext uri="{FF2B5EF4-FFF2-40B4-BE49-F238E27FC236}">
-                <a16:creationId xmlns:a16="http://schemas.microsoft.com/office/drawing/2014/main" id="{F5DBC5CD-6815-449F-AE89-18606409B8F3}"/>
+                <a16:creationId xmlns:a16="http://schemas.microsoft.com/office/drawing/2014/main" id="{2901734C-0B19-4125-99EA-E8AE930F9979}"/>
               </a:ext>
             </a:extLst>
           </p:cNvPr>
@@ -4910,7 +4910,7 @@
           <p:cNvPr id="10" name="s2-current-b">
             <a:extLst xmlns:a="http://schemas.openxmlformats.org/drawingml/2006/main">
               <a:ext uri="{FF2B5EF4-FFF2-40B4-BE49-F238E27FC236}">
-                <a16:creationId xmlns:a16="http://schemas.microsoft.com/office/drawing/2014/main" id="{E69D6C58-BB7F-4DB6-96A2-2CD96E4DB1F2}"/>
+                <a16:creationId xmlns:a16="http://schemas.microsoft.com/office/drawing/2014/main" id="{F19C2C0D-6523-461F-9E0E-87920DE22E42}"/>
               </a:ext>
             </a:extLst>
           </p:cNvPr>
@@ -4941,7 +4941,7 @@
           <p:cNvPr id="11" name="s2-current-b-head">
             <a:extLst xmlns:a="http://schemas.openxmlformats.org/drawingml/2006/main">
               <a:ext uri="{FF2B5EF4-FFF2-40B4-BE49-F238E27FC236}">
-                <a16:creationId xmlns:a16="http://schemas.microsoft.com/office/drawing/2014/main" id="{4EAB092C-17BB-4D38-8250-8187019A6D82}"/>
+                <a16:creationId xmlns:a16="http://schemas.microsoft.com/office/drawing/2014/main" id="{39B42442-C936-4D5F-8BCE-4DECC6281CC4}"/>
               </a:ext>
             </a:extLst>
           </p:cNvPr>
@@ -4974,7 +4974,7 @@
           <p:cNvPr id="12" name="s2-current-c">
             <a:extLst xmlns:a="http://schemas.openxmlformats.org/drawingml/2006/main">
               <a:ext uri="{FF2B5EF4-FFF2-40B4-BE49-F238E27FC236}">
-                <a16:creationId xmlns:a16="http://schemas.microsoft.com/office/drawing/2014/main" id="{0D28D400-866B-4F6F-9DDD-1BB356E520F0}"/>
+                <a16:creationId xmlns:a16="http://schemas.microsoft.com/office/drawing/2014/main" id="{76AF5F40-13F7-4E6C-842E-2D4E953FD58B}"/>
               </a:ext>
             </a:extLst>
           </p:cNvPr>
@@ -5005,7 +5005,7 @@
           <p:cNvPr id="13" name="s2-current-c-head">
             <a:extLst xmlns:a="http://schemas.openxmlformats.org/drawingml/2006/main">
               <a:ext uri="{FF2B5EF4-FFF2-40B4-BE49-F238E27FC236}">
-                <a16:creationId xmlns:a16="http://schemas.microsoft.com/office/drawing/2014/main" id="{F8AF328E-121E-453E-A961-46A18E9F0557}"/>
+                <a16:creationId xmlns:a16="http://schemas.microsoft.com/office/drawing/2014/main" id="{F91F1BE7-C06F-42D9-BDFD-6845E99FB0D9}"/>
               </a:ext>
             </a:extLst>
           </p:cNvPr>
@@ -5038,7 +5038,7 @@
           <p:cNvPr id="14" name="s2-tts-route">
             <a:extLst xmlns:a="http://schemas.openxmlformats.org/drawingml/2006/main">
               <a:ext uri="{FF2B5EF4-FFF2-40B4-BE49-F238E27FC236}">
-                <a16:creationId xmlns:a16="http://schemas.microsoft.com/office/drawing/2014/main" id="{87B9D8A0-FF57-47C0-A068-6A7351842EA4}"/>
+                <a16:creationId xmlns:a16="http://schemas.microsoft.com/office/drawing/2014/main" id="{1A6B1C4B-63FE-45A8-A572-7FA4CD374EE7}"/>
               </a:ext>
             </a:extLst>
           </p:cNvPr>
@@ -5069,7 +5069,7 @@
           <p:cNvPr id="15" name="s2-tts-route-head">
             <a:extLst xmlns:a="http://schemas.openxmlformats.org/drawingml/2006/main">
               <a:ext uri="{FF2B5EF4-FFF2-40B4-BE49-F238E27FC236}">
-                <a16:creationId xmlns:a16="http://schemas.microsoft.com/office/drawing/2014/main" id="{00C954B2-B055-4E69-8A1A-84C3BD51CC1F}"/>
+                <a16:creationId xmlns:a16="http://schemas.microsoft.com/office/drawing/2014/main" id="{61E047E0-D45E-4616-9127-DEECB2801850}"/>
               </a:ext>
             </a:extLst>
           </p:cNvPr>
@@ -5102,7 +5102,7 @@
           <p:cNvPr id="16" name="s2-video-route">
             <a:extLst xmlns:a="http://schemas.openxmlformats.org/drawingml/2006/main">
               <a:ext uri="{FF2B5EF4-FFF2-40B4-BE49-F238E27FC236}">
-                <a16:creationId xmlns:a16="http://schemas.microsoft.com/office/drawing/2014/main" id="{54D0403F-AE9E-483E-B3C4-9FB1F4663AB9}"/>
+                <a16:creationId xmlns:a16="http://schemas.microsoft.com/office/drawing/2014/main" id="{24CE37F8-BA7F-44CE-A8C7-45B9CDDECAFE}"/>
               </a:ext>
             </a:extLst>
           </p:cNvPr>
@@ -5122,9 +5122,9 @@
           <a:noFill xmlns:a="http://schemas.openxmlformats.org/drawingml/2006/main"/>
           <a:ln xmlns:a="http://schemas.openxmlformats.org/drawingml/2006/main" w="22860">
             <a:solidFill>
-              <a:srgbClr val="F38B2A"/>
-            </a:solidFill>
-            <a:prstDash val="dash"/>
+              <a:srgbClr val="147EBA"/>
+            </a:solidFill>
+            <a:prstDash val="solid"/>
           </a:ln>
         </p:spPr>
       </p:sp>
@@ -5133,7 +5133,7 @@
           <p:cNvPr id="17" name="s2-video-route-head">
             <a:extLst xmlns:a="http://schemas.openxmlformats.org/drawingml/2006/main">
               <a:ext uri="{FF2B5EF4-FFF2-40B4-BE49-F238E27FC236}">
-                <a16:creationId xmlns:a16="http://schemas.microsoft.com/office/drawing/2014/main" id="{058B0BD2-F912-4133-A124-62D1742E8729}"/>
+                <a16:creationId xmlns:a16="http://schemas.microsoft.com/office/drawing/2014/main" id="{65FBB41E-DC03-407F-86E7-8729C47FA5DB}"/>
               </a:ext>
             </a:extLst>
           </p:cNvPr>
@@ -5151,11 +5151,11 @@
             <a:avLst/>
           </a:prstGeom>
           <a:solidFill xmlns:a="http://schemas.openxmlformats.org/drawingml/2006/main">
-            <a:srgbClr val="F38B2A"/>
+            <a:srgbClr val="147EBA"/>
           </a:solidFill>
           <a:ln xmlns:a="http://schemas.openxmlformats.org/drawingml/2006/main" w="0">
             <a:solidFill>
-              <a:srgbClr val="F38B2A"/>
+              <a:srgbClr val="147EBA"/>
             </a:solidFill>
             <a:prstDash val="solid"/>
           </a:ln>
@@ -5166,7 +5166,7 @@
           <p:cNvPr id="18" name="s2-tts-result">
             <a:extLst xmlns:a="http://schemas.openxmlformats.org/drawingml/2006/main">
               <a:ext uri="{FF2B5EF4-FFF2-40B4-BE49-F238E27FC236}">
-                <a16:creationId xmlns:a16="http://schemas.microsoft.com/office/drawing/2014/main" id="{A986B10E-0DEB-40DB-B454-5FF07F0B6682}"/>
+                <a16:creationId xmlns:a16="http://schemas.microsoft.com/office/drawing/2014/main" id="{FF245B72-E069-4AD3-BB4D-7264CC1F1016}"/>
               </a:ext>
             </a:extLst>
           </p:cNvPr>
@@ -5197,7 +5197,7 @@
           <p:cNvPr id="19" name="s2-tts-result-head">
             <a:extLst xmlns:a="http://schemas.openxmlformats.org/drawingml/2006/main">
               <a:ext uri="{FF2B5EF4-FFF2-40B4-BE49-F238E27FC236}">
-                <a16:creationId xmlns:a16="http://schemas.microsoft.com/office/drawing/2014/main" id="{C54C05DB-D603-48C9-B8D3-D95927E46138}"/>
+                <a16:creationId xmlns:a16="http://schemas.microsoft.com/office/drawing/2014/main" id="{058BB408-357A-4347-B77F-BEC0E0FAED1F}"/>
               </a:ext>
             </a:extLst>
           </p:cNvPr>
@@ -5230,7 +5230,7 @@
           <p:cNvPr id="20" name="s2-video-result">
             <a:extLst xmlns:a="http://schemas.openxmlformats.org/drawingml/2006/main">
               <a:ext uri="{FF2B5EF4-FFF2-40B4-BE49-F238E27FC236}">
-                <a16:creationId xmlns:a16="http://schemas.microsoft.com/office/drawing/2014/main" id="{A1ABD8CF-A50A-485A-A127-25D7F647577C}"/>
+                <a16:creationId xmlns:a16="http://schemas.microsoft.com/office/drawing/2014/main" id="{729E9E99-971E-47BA-BA2B-4CC82D0AA378}"/>
               </a:ext>
             </a:extLst>
           </p:cNvPr>
@@ -5250,9 +5250,9 @@
           <a:noFill xmlns:a="http://schemas.openxmlformats.org/drawingml/2006/main"/>
           <a:ln xmlns:a="http://schemas.openxmlformats.org/drawingml/2006/main" w="22860">
             <a:solidFill>
-              <a:srgbClr val="F38B2A"/>
-            </a:solidFill>
-            <a:prstDash val="dash"/>
+              <a:srgbClr val="147EBA"/>
+            </a:solidFill>
+            <a:prstDash val="solid"/>
           </a:ln>
         </p:spPr>
       </p:sp>
@@ -5261,7 +5261,7 @@
           <p:cNvPr id="21" name="s2-video-result-head">
             <a:extLst xmlns:a="http://schemas.openxmlformats.org/drawingml/2006/main">
               <a:ext uri="{FF2B5EF4-FFF2-40B4-BE49-F238E27FC236}">
-                <a16:creationId xmlns:a16="http://schemas.microsoft.com/office/drawing/2014/main" id="{D150C1D3-4C63-4BE1-8D2D-878E5684F06A}"/>
+                <a16:creationId xmlns:a16="http://schemas.microsoft.com/office/drawing/2014/main" id="{620EE91D-A270-41E7-858E-3CC3FA6BC740}"/>
               </a:ext>
             </a:extLst>
           </p:cNvPr>
@@ -5279,11 +5279,11 @@
             <a:avLst/>
           </a:prstGeom>
           <a:solidFill xmlns:a="http://schemas.openxmlformats.org/drawingml/2006/main">
-            <a:srgbClr val="F38B2A"/>
+            <a:srgbClr val="147EBA"/>
           </a:solidFill>
           <a:ln xmlns:a="http://schemas.openxmlformats.org/drawingml/2006/main" w="0">
             <a:solidFill>
-              <a:srgbClr val="F38B2A"/>
+              <a:srgbClr val="147EBA"/>
             </a:solidFill>
             <a:prstDash val="solid"/>
           </a:ln>
@@ -5294,7 +5294,7 @@
           <p:cNvPr id="22" name="s2-route">
             <a:extLst xmlns:a="http://schemas.openxmlformats.org/drawingml/2006/main">
               <a:ext uri="{FF2B5EF4-FFF2-40B4-BE49-F238E27FC236}">
-                <a16:creationId xmlns:a16="http://schemas.microsoft.com/office/drawing/2014/main" id="{A9326023-3EBC-4DC1-8110-555BB866BC81}"/>
+                <a16:creationId xmlns:a16="http://schemas.microsoft.com/office/drawing/2014/main" id="{B755DBEA-9379-4A28-9221-22DC0FF90AA4}"/>
               </a:ext>
             </a:extLst>
           </p:cNvPr>
@@ -5329,7 +5329,7 @@
           <p:cNvPr id="23" name="s2-route-accent">
             <a:extLst xmlns:a="http://schemas.openxmlformats.org/drawingml/2006/main">
               <a:ext uri="{FF2B5EF4-FFF2-40B4-BE49-F238E27FC236}">
-                <a16:creationId xmlns:a16="http://schemas.microsoft.com/office/drawing/2014/main" id="{76450BD3-BB8F-40F3-93BD-7747ADD2102A}"/>
+                <a16:creationId xmlns:a16="http://schemas.microsoft.com/office/drawing/2014/main" id="{6D8D4A40-3968-45C0-B36C-DA12D400DC6C}"/>
               </a:ext>
             </a:extLst>
           </p:cNvPr>
@@ -5362,7 +5362,7 @@
           <p:cNvPr id="24" name="s2-route-label">
             <a:extLst xmlns:a="http://schemas.openxmlformats.org/drawingml/2006/main">
               <a:ext uri="{FF2B5EF4-FFF2-40B4-BE49-F238E27FC236}">
-                <a16:creationId xmlns:a16="http://schemas.microsoft.com/office/drawing/2014/main" id="{F1A43949-FFF4-4B50-96C0-A54599E0B982}"/>
+                <a16:creationId xmlns:a16="http://schemas.microsoft.com/office/drawing/2014/main" id="{FE4D5CA5-236B-46BE-BB53-3BA11FAA0CA2}"/>
               </a:ext>
             </a:extLst>
           </p:cNvPr>
@@ -5412,7 +5412,7 @@
           <p:cNvPr id="25" name="s2-route-detail">
             <a:extLst xmlns:a="http://schemas.openxmlformats.org/drawingml/2006/main">
               <a:ext uri="{FF2B5EF4-FFF2-40B4-BE49-F238E27FC236}">
-                <a16:creationId xmlns:a16="http://schemas.microsoft.com/office/drawing/2014/main" id="{82D3A0E5-C360-4F47-B095-983072AC2CFB}"/>
+                <a16:creationId xmlns:a16="http://schemas.microsoft.com/office/drawing/2014/main" id="{61C1AA59-446D-40FD-BD2F-C26E76B23CD8}"/>
               </a:ext>
             </a:extLst>
           </p:cNvPr>
@@ -5462,7 +5462,7 @@
           <p:cNvPr id="26" name="s2-media">
             <a:extLst xmlns:a="http://schemas.openxmlformats.org/drawingml/2006/main">
               <a:ext uri="{FF2B5EF4-FFF2-40B4-BE49-F238E27FC236}">
-                <a16:creationId xmlns:a16="http://schemas.microsoft.com/office/drawing/2014/main" id="{334B1C7C-5F2B-46A9-BBFF-C4B2D8BBAC20}"/>
+                <a16:creationId xmlns:a16="http://schemas.microsoft.com/office/drawing/2014/main" id="{CCDA67C1-B9A1-4FDF-AF6B-AC9A4D132B45}"/>
               </a:ext>
             </a:extLst>
           </p:cNvPr>
@@ -5497,7 +5497,7 @@
           <p:cNvPr id="27" name="s2-media-accent">
             <a:extLst xmlns:a="http://schemas.openxmlformats.org/drawingml/2006/main">
               <a:ext uri="{FF2B5EF4-FFF2-40B4-BE49-F238E27FC236}">
-                <a16:creationId xmlns:a16="http://schemas.microsoft.com/office/drawing/2014/main" id="{B6A40AD0-67CD-4A06-947F-E04177B51A95}"/>
+                <a16:creationId xmlns:a16="http://schemas.microsoft.com/office/drawing/2014/main" id="{30D938A4-F06A-42F5-A6EB-67AF927EDE4D}"/>
               </a:ext>
             </a:extLst>
           </p:cNvPr>
@@ -5530,7 +5530,7 @@
           <p:cNvPr id="28" name="s2-media-label">
             <a:extLst xmlns:a="http://schemas.openxmlformats.org/drawingml/2006/main">
               <a:ext uri="{FF2B5EF4-FFF2-40B4-BE49-F238E27FC236}">
-                <a16:creationId xmlns:a16="http://schemas.microsoft.com/office/drawing/2014/main" id="{F5E1D6EE-E38C-4AA8-84E3-6975EAEC1FBF}"/>
+                <a16:creationId xmlns:a16="http://schemas.microsoft.com/office/drawing/2014/main" id="{C89828FC-9A9B-4761-80DE-2F8C9D32BC79}"/>
               </a:ext>
             </a:extLst>
           </p:cNvPr>
@@ -5580,7 +5580,7 @@
           <p:cNvPr id="29" name="s2-media-detail">
             <a:extLst xmlns:a="http://schemas.openxmlformats.org/drawingml/2006/main">
               <a:ext uri="{FF2B5EF4-FFF2-40B4-BE49-F238E27FC236}">
-                <a16:creationId xmlns:a16="http://schemas.microsoft.com/office/drawing/2014/main" id="{9AA70756-D45F-4B3C-AC87-C1C2FF9061DD}"/>
+                <a16:creationId xmlns:a16="http://schemas.microsoft.com/office/drawing/2014/main" id="{F95A09BA-2AF7-44A9-A456-8AC73E9643F6}"/>
               </a:ext>
             </a:extLst>
           </p:cNvPr>
@@ -5630,7 +5630,7 @@
           <p:cNvPr id="30" name="s2-current">
             <a:extLst xmlns:a="http://schemas.openxmlformats.org/drawingml/2006/main">
               <a:ext uri="{FF2B5EF4-FFF2-40B4-BE49-F238E27FC236}">
-                <a16:creationId xmlns:a16="http://schemas.microsoft.com/office/drawing/2014/main" id="{49849B2B-C18C-4878-A168-E68BF061D8CB}"/>
+                <a16:creationId xmlns:a16="http://schemas.microsoft.com/office/drawing/2014/main" id="{5A53EEA2-A3A6-4255-BAC9-9551A972B356}"/>
               </a:ext>
             </a:extLst>
           </p:cNvPr>
@@ -5665,7 +5665,7 @@
           <p:cNvPr id="31" name="s2-current-accent">
             <a:extLst xmlns:a="http://schemas.openxmlformats.org/drawingml/2006/main">
               <a:ext uri="{FF2B5EF4-FFF2-40B4-BE49-F238E27FC236}">
-                <a16:creationId xmlns:a16="http://schemas.microsoft.com/office/drawing/2014/main" id="{D1E95FB7-C4F7-4806-B034-D14CAA109456}"/>
+                <a16:creationId xmlns:a16="http://schemas.microsoft.com/office/drawing/2014/main" id="{43F4D936-D13D-4BE6-9DAC-18BF38EDD1A1}"/>
               </a:ext>
             </a:extLst>
           </p:cNvPr>
@@ -5698,7 +5698,7 @@
           <p:cNvPr id="32" name="s2-current-label">
             <a:extLst xmlns:a="http://schemas.openxmlformats.org/drawingml/2006/main">
               <a:ext uri="{FF2B5EF4-FFF2-40B4-BE49-F238E27FC236}">
-                <a16:creationId xmlns:a16="http://schemas.microsoft.com/office/drawing/2014/main" id="{04CE32FF-770F-45D8-9957-F7FA85F777B8}"/>
+                <a16:creationId xmlns:a16="http://schemas.microsoft.com/office/drawing/2014/main" id="{85FC1386-2E66-4ED6-8D89-A13873972D1B}"/>
               </a:ext>
             </a:extLst>
           </p:cNvPr>
@@ -5748,7 +5748,7 @@
           <p:cNvPr id="33" name="s2-current-detail">
             <a:extLst xmlns:a="http://schemas.openxmlformats.org/drawingml/2006/main">
               <a:ext uri="{FF2B5EF4-FFF2-40B4-BE49-F238E27FC236}">
-                <a16:creationId xmlns:a16="http://schemas.microsoft.com/office/drawing/2014/main" id="{FE889544-BFCA-4B26-B4C8-18B8CB34F24D}"/>
+                <a16:creationId xmlns:a16="http://schemas.microsoft.com/office/drawing/2014/main" id="{198171EA-721C-4809-B077-BE2259901FB1}"/>
               </a:ext>
             </a:extLst>
           </p:cNvPr>
@@ -5788,7 +5788,7 @@
                   <a:srgbClr val="5D7180"/>
                 </a:solidFill>
               </a:rPr>
-              <a:t>事前生成動画 または 写真アニメ + 動的音声 + 字幕</a:t>
+              <a:t>保存MP4 + 動的音声 + 字幕</a:t>
             </a:r>
           </a:p>
         </p:txBody>
@@ -5798,7 +5798,7 @@
           <p:cNvPr id="34" name="s2-safety">
             <a:extLst xmlns:a="http://schemas.openxmlformats.org/drawingml/2006/main">
               <a:ext uri="{FF2B5EF4-FFF2-40B4-BE49-F238E27FC236}">
-                <a16:creationId xmlns:a16="http://schemas.microsoft.com/office/drawing/2014/main" id="{80303AB2-197D-4152-B4DF-0FB7C54BAA4D}"/>
+                <a16:creationId xmlns:a16="http://schemas.microsoft.com/office/drawing/2014/main" id="{599EBC8E-FD45-432E-8458-82ECC33C5AA0}"/>
               </a:ext>
             </a:extLst>
           </p:cNvPr>
@@ -5833,7 +5833,7 @@
           <p:cNvPr id="35" name="s2-safety-accent">
             <a:extLst xmlns:a="http://schemas.openxmlformats.org/drawingml/2006/main">
               <a:ext uri="{FF2B5EF4-FFF2-40B4-BE49-F238E27FC236}">
-                <a16:creationId xmlns:a16="http://schemas.microsoft.com/office/drawing/2014/main" id="{EEF0B56E-29A9-4374-9D25-29C8EE61D7AA}"/>
+                <a16:creationId xmlns:a16="http://schemas.microsoft.com/office/drawing/2014/main" id="{C0438676-2CFF-4A61-B3C0-52F5BFC9537D}"/>
               </a:ext>
             </a:extLst>
           </p:cNvPr>
@@ -5866,7 +5866,7 @@
           <p:cNvPr id="36" name="s2-safety-label">
             <a:extLst xmlns:a="http://schemas.openxmlformats.org/drawingml/2006/main">
               <a:ext uri="{FF2B5EF4-FFF2-40B4-BE49-F238E27FC236}">
-                <a16:creationId xmlns:a16="http://schemas.microsoft.com/office/drawing/2014/main" id="{8A5FACCD-988F-44A6-9983-DEA1C2032666}"/>
+                <a16:creationId xmlns:a16="http://schemas.microsoft.com/office/drawing/2014/main" id="{37966299-A2BC-41D2-AFAD-7CC208BF161C}"/>
               </a:ext>
             </a:extLst>
           </p:cNvPr>
@@ -5916,7 +5916,7 @@
           <p:cNvPr id="37" name="s2-safety-detail">
             <a:extLst xmlns:a="http://schemas.openxmlformats.org/drawingml/2006/main">
               <a:ext uri="{FF2B5EF4-FFF2-40B4-BE49-F238E27FC236}">
-                <a16:creationId xmlns:a16="http://schemas.microsoft.com/office/drawing/2014/main" id="{BF5D59FD-DF62-4339-84BB-68E839DA7A76}"/>
+                <a16:creationId xmlns:a16="http://schemas.microsoft.com/office/drawing/2014/main" id="{8814B830-996B-48EC-BF6D-2459D79CF354}"/>
               </a:ext>
             </a:extLst>
           </p:cNvPr>
@@ -5966,7 +5966,7 @@
           <p:cNvPr id="38" name="s2-gateway">
             <a:extLst xmlns:a="http://schemas.openxmlformats.org/drawingml/2006/main">
               <a:ext uri="{FF2B5EF4-FFF2-40B4-BE49-F238E27FC236}">
-                <a16:creationId xmlns:a16="http://schemas.microsoft.com/office/drawing/2014/main" id="{1D792BD9-B6C4-43AC-ADFD-950CF8F62F30}"/>
+                <a16:creationId xmlns:a16="http://schemas.microsoft.com/office/drawing/2014/main" id="{FFE6F66B-4472-47B6-95F7-F8E0D2FCB0C5}"/>
               </a:ext>
             </a:extLst>
           </p:cNvPr>
@@ -6001,7 +6001,7 @@
           <p:cNvPr id="39" name="s2-gateway-accent">
             <a:extLst xmlns:a="http://schemas.openxmlformats.org/drawingml/2006/main">
               <a:ext uri="{FF2B5EF4-FFF2-40B4-BE49-F238E27FC236}">
-                <a16:creationId xmlns:a16="http://schemas.microsoft.com/office/drawing/2014/main" id="{FFC86E7E-3B02-4DBE-81DF-3A839E2B1C6A}"/>
+                <a16:creationId xmlns:a16="http://schemas.microsoft.com/office/drawing/2014/main" id="{320ACA44-B4AF-49BC-B3E5-9822AF8DE644}"/>
               </a:ext>
             </a:extLst>
           </p:cNvPr>
@@ -6034,7 +6034,7 @@
           <p:cNvPr id="40" name="s2-gateway-label">
             <a:extLst xmlns:a="http://schemas.openxmlformats.org/drawingml/2006/main">
               <a:ext uri="{FF2B5EF4-FFF2-40B4-BE49-F238E27FC236}">
-                <a16:creationId xmlns:a16="http://schemas.microsoft.com/office/drawing/2014/main" id="{82101D80-1433-4BB2-A1B5-A582844B4C37}"/>
+                <a16:creationId xmlns:a16="http://schemas.microsoft.com/office/drawing/2014/main" id="{5737FD35-92E4-4878-94DA-4FB58A04B076}"/>
               </a:ext>
             </a:extLst>
           </p:cNvPr>
@@ -6084,7 +6084,7 @@
           <p:cNvPr id="41" name="s2-gateway-detail">
             <a:extLst xmlns:a="http://schemas.openxmlformats.org/drawingml/2006/main">
               <a:ext uri="{FF2B5EF4-FFF2-40B4-BE49-F238E27FC236}">
-                <a16:creationId xmlns:a16="http://schemas.microsoft.com/office/drawing/2014/main" id="{FC05ABCF-0BB6-4D43-A27C-F971F8685353}"/>
+                <a16:creationId xmlns:a16="http://schemas.microsoft.com/office/drawing/2014/main" id="{BB439AC3-D245-49E7-B44A-EBCA7143087A}"/>
               </a:ext>
             </a:extLst>
           </p:cNvPr>
@@ -6124,7 +6124,7 @@
                   <a:srgbClr val="5D7180"/>
                 </a:solidFill>
               </a:rPr>
-              <a:t>TTS / 動画モデルへルーティング可能</a:t>
+              <a:t>Kling動画へルーティング／外部TTSも追加可能</a:t>
             </a:r>
           </a:p>
         </p:txBody>
@@ -6134,7 +6134,7 @@
           <p:cNvPr id="42" name="s2-tts">
             <a:extLst xmlns:a="http://schemas.openxmlformats.org/drawingml/2006/main">
               <a:ext uri="{FF2B5EF4-FFF2-40B4-BE49-F238E27FC236}">
-                <a16:creationId xmlns:a16="http://schemas.microsoft.com/office/drawing/2014/main" id="{932CDEE7-AFCF-4089-8F23-566B68848C36}"/>
+                <a16:creationId xmlns:a16="http://schemas.microsoft.com/office/drawing/2014/main" id="{E9EFD575-2E42-492C-8C66-151CD2F2B771}"/>
               </a:ext>
             </a:extLst>
           </p:cNvPr>
@@ -6169,7 +6169,7 @@
           <p:cNvPr id="43" name="s2-tts-accent">
             <a:extLst xmlns:a="http://schemas.openxmlformats.org/drawingml/2006/main">
               <a:ext uri="{FF2B5EF4-FFF2-40B4-BE49-F238E27FC236}">
-                <a16:creationId xmlns:a16="http://schemas.microsoft.com/office/drawing/2014/main" id="{54B77598-8989-4B70-A2F9-B9A602D5081C}"/>
+                <a16:creationId xmlns:a16="http://schemas.microsoft.com/office/drawing/2014/main" id="{14895FE8-C6FF-4796-B9C6-70B28EBEAE56}"/>
               </a:ext>
             </a:extLst>
           </p:cNvPr>
@@ -6202,7 +6202,7 @@
           <p:cNvPr id="44" name="s2-tts-label">
             <a:extLst xmlns:a="http://schemas.openxmlformats.org/drawingml/2006/main">
               <a:ext uri="{FF2B5EF4-FFF2-40B4-BE49-F238E27FC236}">
-                <a16:creationId xmlns:a16="http://schemas.microsoft.com/office/drawing/2014/main" id="{A10F8DCC-B55F-4DF5-8B72-19C000FF6AA4}"/>
+                <a16:creationId xmlns:a16="http://schemas.microsoft.com/office/drawing/2014/main" id="{43B3B2E4-5F3E-496E-A064-8F248ABF0B65}"/>
               </a:ext>
             </a:extLst>
           </p:cNvPr>
@@ -6252,7 +6252,7 @@
           <p:cNvPr id="45" name="s2-tts-detail">
             <a:extLst xmlns:a="http://schemas.openxmlformats.org/drawingml/2006/main">
               <a:ext uri="{FF2B5EF4-FFF2-40B4-BE49-F238E27FC236}">
-                <a16:creationId xmlns:a16="http://schemas.microsoft.com/office/drawing/2014/main" id="{57C0D16B-E2F8-4525-AECE-77B5F18B563F}"/>
+                <a16:creationId xmlns:a16="http://schemas.microsoft.com/office/drawing/2014/main" id="{9DF2376D-AD41-42FB-AE2D-D578B61352CB}"/>
               </a:ext>
             </a:extLst>
           </p:cNvPr>
@@ -6319,7 +6319,7 @@
           <p:cNvPr id="46" name="s2-video">
             <a:extLst xmlns:a="http://schemas.openxmlformats.org/drawingml/2006/main">
               <a:ext uri="{FF2B5EF4-FFF2-40B4-BE49-F238E27FC236}">
-                <a16:creationId xmlns:a16="http://schemas.microsoft.com/office/drawing/2014/main" id="{82495660-7149-40C1-A04F-82011F99BE1B}"/>
+                <a16:creationId xmlns:a16="http://schemas.microsoft.com/office/drawing/2014/main" id="{7B5AB1CC-4F98-4013-BE92-1049451EA848}"/>
               </a:ext>
             </a:extLst>
           </p:cNvPr>
@@ -6339,11 +6339,11 @@
             </a:avLst>
           </a:prstGeom>
           <a:solidFill xmlns:a="http://schemas.openxmlformats.org/drawingml/2006/main">
-            <a:srgbClr val="FFF2E5"/>
+            <a:srgbClr val="EAF6FC"/>
           </a:solidFill>
           <a:ln xmlns:a="http://schemas.openxmlformats.org/drawingml/2006/main" w="13335">
             <a:solidFill>
-              <a:srgbClr val="F38B2A"/>
+              <a:srgbClr val="147EBA"/>
             </a:solidFill>
             <a:prstDash val="solid"/>
           </a:ln>
@@ -6354,7 +6354,7 @@
           <p:cNvPr id="47" name="s2-video-accent">
             <a:extLst xmlns:a="http://schemas.openxmlformats.org/drawingml/2006/main">
               <a:ext uri="{FF2B5EF4-FFF2-40B4-BE49-F238E27FC236}">
-                <a16:creationId xmlns:a16="http://schemas.microsoft.com/office/drawing/2014/main" id="{EADBF57F-FF9B-4A92-94D4-AC7219B352A7}"/>
+                <a16:creationId xmlns:a16="http://schemas.microsoft.com/office/drawing/2014/main" id="{F1C6BDB9-E674-41DD-858B-AB5EC9661BE8}"/>
               </a:ext>
             </a:extLst>
           </p:cNvPr>
@@ -6372,11 +6372,11 @@
             <a:avLst/>
           </a:prstGeom>
           <a:solidFill xmlns:a="http://schemas.openxmlformats.org/drawingml/2006/main">
-            <a:srgbClr val="F38B2A"/>
+            <a:srgbClr val="147EBA"/>
           </a:solidFill>
           <a:ln xmlns:a="http://schemas.openxmlformats.org/drawingml/2006/main" w="13335">
             <a:solidFill>
-              <a:srgbClr val="F38B2A"/>
+              <a:srgbClr val="147EBA"/>
             </a:solidFill>
             <a:prstDash val="solid"/>
           </a:ln>
@@ -6387,7 +6387,7 @@
           <p:cNvPr id="48" name="s2-video-label">
             <a:extLst xmlns:a="http://schemas.openxmlformats.org/drawingml/2006/main">
               <a:ext uri="{FF2B5EF4-FFF2-40B4-BE49-F238E27FC236}">
-                <a16:creationId xmlns:a16="http://schemas.microsoft.com/office/drawing/2014/main" id="{DD3757C3-A058-410A-ACF4-29152D961D68}"/>
+                <a16:creationId xmlns:a16="http://schemas.microsoft.com/office/drawing/2014/main" id="{DF26CFB0-8C77-48B7-9458-A2EA0876FB44}"/>
               </a:ext>
             </a:extLst>
           </p:cNvPr>
@@ -6427,7 +6427,7 @@
                   <a:srgbClr val="172B3A"/>
                 </a:solidFill>
               </a:rPr>
-              <a:t>非同期動画</a:t>
+              <a:t>Kling実動画（実装済み）</a:t>
             </a:r>
           </a:p>
         </p:txBody>
@@ -6437,7 +6437,7 @@
           <p:cNvPr id="49" name="s2-video-detail">
             <a:extLst xmlns:a="http://schemas.openxmlformats.org/drawingml/2006/main">
               <a:ext uri="{FF2B5EF4-FFF2-40B4-BE49-F238E27FC236}">
-                <a16:creationId xmlns:a16="http://schemas.microsoft.com/office/drawing/2014/main" id="{29DEBC5F-9977-482B-ADF9-675E51084A49}"/>
+                <a16:creationId xmlns:a16="http://schemas.microsoft.com/office/drawing/2014/main" id="{6FD5CC37-6D08-4E3D-8595-B2DDE587828D}"/>
               </a:ext>
             </a:extLst>
           </p:cNvPr>
@@ -6494,7 +6494,7 @@
                   <a:srgbClr val="5D7180"/>
                 </a:solidFill>
               </a:rPr>
-              <a:t>Kling / Seedance：30秒以上</a:t>
+              <a:t>登録写真 → 約5秒MP4</a:t>
             </a:r>
           </a:p>
         </p:txBody>
@@ -6504,7 +6504,7 @@
           <p:cNvPr id="50" name="s2-realtime">
             <a:extLst xmlns:a="http://schemas.openxmlformats.org/drawingml/2006/main">
               <a:ext uri="{FF2B5EF4-FFF2-40B4-BE49-F238E27FC236}">
-                <a16:creationId xmlns:a16="http://schemas.microsoft.com/office/drawing/2014/main" id="{0C3706E5-79D1-4D15-BFF0-518572C05336}"/>
+                <a16:creationId xmlns:a16="http://schemas.microsoft.com/office/drawing/2014/main" id="{FFAED919-7A69-4984-9DB5-3B8E43487B7B}"/>
               </a:ext>
             </a:extLst>
           </p:cNvPr>
@@ -6539,7 +6539,7 @@
           <p:cNvPr id="51" name="s2-realtime-accent">
             <a:extLst xmlns:a="http://schemas.openxmlformats.org/drawingml/2006/main">
               <a:ext uri="{FF2B5EF4-FFF2-40B4-BE49-F238E27FC236}">
-                <a16:creationId xmlns:a16="http://schemas.microsoft.com/office/drawing/2014/main" id="{DB9002EB-31FF-4365-9309-B7FDF70746F0}"/>
+                <a16:creationId xmlns:a16="http://schemas.microsoft.com/office/drawing/2014/main" id="{16102897-EA58-40B4-BB89-B745BD2EE819}"/>
               </a:ext>
             </a:extLst>
           </p:cNvPr>
@@ -6572,7 +6572,7 @@
           <p:cNvPr id="52" name="s2-realtime-label">
             <a:extLst xmlns:a="http://schemas.openxmlformats.org/drawingml/2006/main">
               <a:ext uri="{FF2B5EF4-FFF2-40B4-BE49-F238E27FC236}">
-                <a16:creationId xmlns:a16="http://schemas.microsoft.com/office/drawing/2014/main" id="{482A6795-13F7-49CC-8BB9-FACAB9261988}"/>
+                <a16:creationId xmlns:a16="http://schemas.microsoft.com/office/drawing/2014/main" id="{8A4A650F-EBD6-4475-8BBB-760C410DD152}"/>
               </a:ext>
             </a:extLst>
           </p:cNvPr>
@@ -6612,7 +6612,7 @@
                   <a:srgbClr val="172B3A"/>
                 </a:solidFill>
               </a:rPr>
-              <a:t>リアルタイム会話に採用</a:t>
+              <a:t>会話時の同時再生</a:t>
             </a:r>
           </a:p>
         </p:txBody>
@@ -6622,7 +6622,7 @@
           <p:cNvPr id="53" name="s2-realtime-detail">
             <a:extLst xmlns:a="http://schemas.openxmlformats.org/drawingml/2006/main">
               <a:ext uri="{FF2B5EF4-FFF2-40B4-BE49-F238E27FC236}">
-                <a16:creationId xmlns:a16="http://schemas.microsoft.com/office/drawing/2014/main" id="{E224102E-ADD3-4242-904F-6BCC6D6D63F5}"/>
+                <a16:creationId xmlns:a16="http://schemas.microsoft.com/office/drawing/2014/main" id="{07832720-A120-4E25-A05F-297A6931B415}"/>
               </a:ext>
             </a:extLst>
           </p:cNvPr>
@@ -6662,7 +6662,7 @@
                   <a:srgbClr val="5D7180"/>
                 </a:solidFill>
               </a:rPr>
-              <a:t>写真アニメ + 動的TTS</a:t>
+              <a:t>保存MP4をループ</a:t>
             </a:r>
           </a:p>
           <a:p xmlns:a="http://schemas.openxmlformats.org/drawingml/2006/main">
@@ -6679,7 +6679,7 @@
                   <a:srgbClr val="5D7180"/>
                 </a:solidFill>
               </a:rPr>
-              <a:t>または事前生成リアクション動画</a:t>
+              <a:t>+ ブラウザ音声 + 字幕</a:t>
             </a:r>
           </a:p>
         </p:txBody>
@@ -6689,7 +6689,7 @@
           <p:cNvPr id="54" name="s2-async">
             <a:extLst xmlns:a="http://schemas.openxmlformats.org/drawingml/2006/main">
               <a:ext uri="{FF2B5EF4-FFF2-40B4-BE49-F238E27FC236}">
-                <a16:creationId xmlns:a16="http://schemas.microsoft.com/office/drawing/2014/main" id="{F77B8A64-96CA-431E-9F95-20DCB69DD32D}"/>
+                <a16:creationId xmlns:a16="http://schemas.microsoft.com/office/drawing/2014/main" id="{6527EBAC-9BC7-4A7C-9068-0CE399E9874A}"/>
               </a:ext>
             </a:extLst>
           </p:cNvPr>
@@ -6724,7 +6724,7 @@
           <p:cNvPr id="55" name="s2-async-accent">
             <a:extLst xmlns:a="http://schemas.openxmlformats.org/drawingml/2006/main">
               <a:ext uri="{FF2B5EF4-FFF2-40B4-BE49-F238E27FC236}">
-                <a16:creationId xmlns:a16="http://schemas.microsoft.com/office/drawing/2014/main" id="{1010CA8E-483D-46CE-836E-40C81A3E8ABC}"/>
+                <a16:creationId xmlns:a16="http://schemas.microsoft.com/office/drawing/2014/main" id="{5CABF863-A2C5-4D91-981A-F8EA6F90A8C5}"/>
               </a:ext>
             </a:extLst>
           </p:cNvPr>
@@ -6757,7 +6757,7 @@
           <p:cNvPr id="56" name="s2-async-label">
             <a:extLst xmlns:a="http://schemas.openxmlformats.org/drawingml/2006/main">
               <a:ext uri="{FF2B5EF4-FFF2-40B4-BE49-F238E27FC236}">
-                <a16:creationId xmlns:a16="http://schemas.microsoft.com/office/drawing/2014/main" id="{FF280D49-3A25-404D-93DD-E25F3E271494}"/>
+                <a16:creationId xmlns:a16="http://schemas.microsoft.com/office/drawing/2014/main" id="{EC0D46D2-77A3-4073-B9C9-86D1DD25C3C3}"/>
               </a:ext>
             </a:extLst>
           </p:cNvPr>
@@ -6797,7 +6797,7 @@
                   <a:srgbClr val="172B3A"/>
                 </a:solidFill>
               </a:rPr>
-              <a:t>バックグラウンド生成</a:t>
+              <a:t>登録時の非同期生成</a:t>
             </a:r>
           </a:p>
         </p:txBody>
@@ -6807,7 +6807,7 @@
           <p:cNvPr id="57" name="s2-async-detail">
             <a:extLst xmlns:a="http://schemas.openxmlformats.org/drawingml/2006/main">
               <a:ext uri="{FF2B5EF4-FFF2-40B4-BE49-F238E27FC236}">
-                <a16:creationId xmlns:a16="http://schemas.microsoft.com/office/drawing/2014/main" id="{7B9F2302-6122-41F7-B739-ED51C61F43DF}"/>
+                <a16:creationId xmlns:a16="http://schemas.microsoft.com/office/drawing/2014/main" id="{621DBCDC-86B1-43D3-A187-4030C4093C38}"/>
               </a:ext>
             </a:extLst>
           </p:cNvPr>
@@ -6847,7 +6847,7 @@
                   <a:srgbClr val="5D7180"/>
                 </a:solidFill>
               </a:rPr>
-              <a:t>submit → poll → MP4</a:t>
+              <a:t>submit → poll → download</a:t>
             </a:r>
           </a:p>
           <a:p xmlns:a="http://schemas.openxmlformats.org/drawingml/2006/main">
@@ -6864,7 +6864,7 @@
                   <a:srgbClr val="5D7180"/>
                 </a:solidFill>
               </a:rPr>
-              <a:t>会話中は完成を待たない</a:t>
+              <a:t>AES-256-GCM保存</a:t>
             </a:r>
           </a:p>
         </p:txBody>
@@ -6874,7 +6874,7 @@
           <p:cNvPr id="58" name="s2-lipsync">
             <a:extLst xmlns:a="http://schemas.openxmlformats.org/drawingml/2006/main">
               <a:ext uri="{FF2B5EF4-FFF2-40B4-BE49-F238E27FC236}">
-                <a16:creationId xmlns:a16="http://schemas.microsoft.com/office/drawing/2014/main" id="{43F4590E-CB5C-4909-8CD3-D3BA60DFB6D6}"/>
+                <a16:creationId xmlns:a16="http://schemas.microsoft.com/office/drawing/2014/main" id="{58A91C95-2080-4397-A5DC-BBC329DE4844}"/>
               </a:ext>
             </a:extLst>
           </p:cNvPr>
@@ -6909,7 +6909,7 @@
           <p:cNvPr id="59" name="s2-lipsync-accent">
             <a:extLst xmlns:a="http://schemas.openxmlformats.org/drawingml/2006/main">
               <a:ext uri="{FF2B5EF4-FFF2-40B4-BE49-F238E27FC236}">
-                <a16:creationId xmlns:a16="http://schemas.microsoft.com/office/drawing/2014/main" id="{873571DB-699C-480C-9ADC-7F9FBF08007E}"/>
+                <a16:creationId xmlns:a16="http://schemas.microsoft.com/office/drawing/2014/main" id="{F25DBF95-9BB1-4CF8-A746-547F6746B87D}"/>
               </a:ext>
             </a:extLst>
           </p:cNvPr>
@@ -6942,7 +6942,7 @@
           <p:cNvPr id="60" name="s2-lipsync-label">
             <a:extLst xmlns:a="http://schemas.openxmlformats.org/drawingml/2006/main">
               <a:ext uri="{FF2B5EF4-FFF2-40B4-BE49-F238E27FC236}">
-                <a16:creationId xmlns:a16="http://schemas.microsoft.com/office/drawing/2014/main" id="{2DFFCDFB-803A-4764-B518-7D3CBA648B6F}"/>
+                <a16:creationId xmlns:a16="http://schemas.microsoft.com/office/drawing/2014/main" id="{320B5CCE-856B-4A4A-A9F4-F85CB180F64F}"/>
               </a:ext>
             </a:extLst>
           </p:cNvPr>
@@ -6992,7 +6992,7 @@
           <p:cNvPr id="61" name="s2-lipsync-detail">
             <a:extLst xmlns:a="http://schemas.openxmlformats.org/drawingml/2006/main">
               <a:ext uri="{FF2B5EF4-FFF2-40B4-BE49-F238E27FC236}">
-                <a16:creationId xmlns:a16="http://schemas.microsoft.com/office/drawing/2014/main" id="{F4B6DEC9-E9A7-4C25-BAC1-8C43652C1A40}"/>
+                <a16:creationId xmlns:a16="http://schemas.microsoft.com/office/drawing/2014/main" id="{4C5CC6EF-83E3-4208-AFE9-6D47416EA1AA}"/>
               </a:ext>
             </a:extLst>
           </p:cNvPr>
@@ -7042,7 +7042,7 @@
           <p:cNvPr id="62" name="footer2">
             <a:extLst xmlns:a="http://schemas.openxmlformats.org/drawingml/2006/main">
               <a:ext uri="{FF2B5EF4-FFF2-40B4-BE49-F238E27FC236}">
-                <a16:creationId xmlns:a16="http://schemas.microsoft.com/office/drawing/2014/main" id="{7DD5C30F-EECD-4878-8266-8E9874BC440B}"/>
+                <a16:creationId xmlns:a16="http://schemas.microsoft.com/office/drawing/2014/main" id="{4F211063-B5E5-424F-AB05-2E3A912291B8}"/>
               </a:ext>
             </a:extLst>
           </p:cNvPr>
@@ -7082,7 +7082,7 @@
                   <a:srgbClr val="5D7180"/>
                 </a:solidFill>
               </a:rPr>
-              <a:t>動画は典型30〜90秒（Kling）／30秒〜4分（Seedance）。即時会話と非同期生成を分離する。</a:t>
+              <a:t>Kling生成は典型30〜90秒。保護者登録時に1回生成し、会話中は完成動画を即時利用する。</a:t>
             </a:r>
           </a:p>
         </p:txBody>
@@ -7092,7 +7092,7 @@
           <p:cNvPr id="63" name="">
             <a:extLst xmlns:a="http://schemas.openxmlformats.org/drawingml/2006/main">
               <a:ext uri="{FF2B5EF4-FFF2-40B4-BE49-F238E27FC236}">
-                <a16:creationId xmlns:a16="http://schemas.microsoft.com/office/drawing/2014/main" id="{8D9F3F65-DD2C-4064-B9C2-DE9209B27A16}"/>
+                <a16:creationId xmlns:a16="http://schemas.microsoft.com/office/drawing/2014/main" id="{3BA68CD7-BE20-4775-B61A-159D65B42D83}"/>
               </a:ext>
             </a:extLst>
           </p:cNvPr>
@@ -7123,7 +7123,7 @@
           <p:cNvPr id="64" name="legend-実装済み">
             <a:extLst xmlns:a="http://schemas.openxmlformats.org/drawingml/2006/main">
               <a:ext uri="{FF2B5EF4-FFF2-40B4-BE49-F238E27FC236}">
-                <a16:creationId xmlns:a16="http://schemas.microsoft.com/office/drawing/2014/main" id="{4AFC58A3-A830-4736-9415-3DC89D107E5D}"/>
+                <a16:creationId xmlns:a16="http://schemas.microsoft.com/office/drawing/2014/main" id="{674A4E3B-6D9C-4001-B9AF-2281E744DF34}"/>
               </a:ext>
             </a:extLst>
           </p:cNvPr>
@@ -7173,7 +7173,7 @@
           <p:cNvPr id="65" name="">
             <a:extLst xmlns:a="http://schemas.openxmlformats.org/drawingml/2006/main">
               <a:ext uri="{FF2B5EF4-FFF2-40B4-BE49-F238E27FC236}">
-                <a16:creationId xmlns:a16="http://schemas.microsoft.com/office/drawing/2014/main" id="{B02CCE01-244F-4795-A5BD-81AAA908207F}"/>
+                <a16:creationId xmlns:a16="http://schemas.microsoft.com/office/drawing/2014/main" id="{3CC6EFC4-1744-4718-AF08-51371E11EFCA}"/>
               </a:ext>
             </a:extLst>
           </p:cNvPr>
@@ -7201,10 +7201,10 @@
       </p:sp>
       <p:sp>
         <p:nvSpPr>
-          <p:cNvPr id="66" name="legend-未実装">
-            <a:extLst xmlns:a="http://schemas.openxmlformats.org/drawingml/2006/main">
-              <a:ext uri="{FF2B5EF4-FFF2-40B4-BE49-F238E27FC236}">
-                <a16:creationId xmlns:a16="http://schemas.microsoft.com/office/drawing/2014/main" id="{1E0A1148-D5BD-4A89-9B56-807F28648211}"/>
+          <p:cNvPr id="66" name="legend-将来">
+            <a:extLst xmlns:a="http://schemas.openxmlformats.org/drawingml/2006/main">
+              <a:ext uri="{FF2B5EF4-FFF2-40B4-BE49-F238E27FC236}">
+                <a16:creationId xmlns:a16="http://schemas.microsoft.com/office/drawing/2014/main" id="{C145DA47-3C52-4682-8096-0C315E7EC40B}"/>
               </a:ext>
             </a:extLst>
           </p:cNvPr>
@@ -7244,7 +7244,7 @@
                   <a:srgbClr val="5D7180"/>
                 </a:solidFill>
               </a:rPr>
-              <a:t>未実装</a:t>
+              <a:t>将来</a:t>
             </a:r>
           </a:p>
         </p:txBody>
@@ -7252,7 +7252,7 @@
     </p:spTree>
     <p:extLst>
       <p:ext uri="{BB962C8B-B14F-4D97-AF65-F5344CB8AC3E}">
-        <p14:creationId xmlns:p14="http://schemas.microsoft.com/office/powerpoint/2010/main" val="1346409311"/>
+        <p14:creationId xmlns:p14="http://schemas.microsoft.com/office/powerpoint/2010/main" val="1849667061"/>
       </p:ext>
     </p:extLst>
   </p:cSld>

</xml_diff>